<commit_message>
docs: deep-dive appendix (glossary AWS/formats/process + per-stage code snippets)
Co-Authored-By: Claude Fable 5 <noreply@anthropic.com>
</commit_message>
<xml_diff>
--- a/docs/prezentacja_etl.pptx
+++ b/docs/prezentacja_etl.pptx
@@ -18,6 +18,14 @@
     <p:sldId id="266" r:id="rId17"/>
     <p:sldId id="267" r:id="rId18"/>
     <p:sldId id="268" r:id="rId19"/>
+    <p:sldId id="269" r:id="rId20"/>
+    <p:sldId id="270" r:id="rId21"/>
+    <p:sldId id="271" r:id="rId22"/>
+    <p:sldId id="272" r:id="rId23"/>
+    <p:sldId id="273" r:id="rId24"/>
+    <p:sldId id="274" r:id="rId25"/>
+    <p:sldId id="275" r:id="rId26"/>
+    <p:sldId id="276" r:id="rId27"/>
   </p:sldIdLst>
   <p:sldSz cx="12191695" cy="6858000" type="screen4x3"/>
   <p:notesSz cx="6858000" cy="9144000"/>
@@ -5346,6 +5354,2868 @@
 </p:sld>
 </file>
 
+<file path=ppt/slides/slide14.xml><?xml version="1.0" encoding="utf-8"?>
+<p:sld xmlns:a="http://schemas.openxmlformats.org/drawingml/2006/main" xmlns:p="http://schemas.openxmlformats.org/presentationml/2006/main" xmlns:r="http://schemas.openxmlformats.org/officeDocument/2006/relationships">
+  <p:cSld>
+    <p:bg>
+      <p:bgPr>
+        <a:solidFill>
+          <a:srgbClr val="F7F7F5"/>
+        </a:solidFill>
+        <a:effectLst/>
+      </p:bgPr>
+    </p:bg>
+    <p:spTree>
+      <p:nvGrpSpPr>
+        <p:cNvPr id="1" name=""/>
+        <p:cNvGrpSpPr/>
+        <p:nvPr/>
+      </p:nvGrpSpPr>
+      <p:grpSpPr/>
+      <p:sp>
+        <p:nvSpPr>
+          <p:cNvPr id="2" name="Rectangle 1"/>
+          <p:cNvSpPr/>
+          <p:nvPr/>
+        </p:nvSpPr>
+        <p:spPr>
+          <a:xfrm>
+            <a:off x="0" y="2651760"/>
+            <a:ext cx="12191695" cy="1463040"/>
+          </a:xfrm>
+          <a:prstGeom prst="rect">
+            <a:avLst/>
+          </a:prstGeom>
+          <a:solidFill>
+            <a:srgbClr val="1F6F8B"/>
+          </a:solidFill>
+          <a:ln>
+            <a:noFill/>
+          </a:ln>
+        </p:spPr>
+        <p:style>
+          <a:lnRef idx="1">
+            <a:schemeClr val="accent1"/>
+          </a:lnRef>
+          <a:fillRef idx="3">
+            <a:schemeClr val="accent1"/>
+          </a:fillRef>
+          <a:effectRef idx="2">
+            <a:schemeClr val="accent1"/>
+          </a:effectRef>
+          <a:fontRef idx="minor">
+            <a:schemeClr val="lt1"/>
+          </a:fontRef>
+        </p:style>
+        <p:txBody>
+          <a:bodyPr rtlCol="0" anchor="ctr"/>
+          <a:lstStyle/>
+          <a:p>
+            <a:pPr algn="ctr"/>
+          </a:p>
+        </p:txBody>
+      </p:sp>
+      <p:sp>
+        <p:nvSpPr>
+          <p:cNvPr id="3" name="TextBox 2"/>
+          <p:cNvSpPr txBox="1"/>
+          <p:nvPr/>
+        </p:nvSpPr>
+        <p:spPr>
+          <a:xfrm>
+            <a:off x="731520" y="2880360"/>
+            <a:ext cx="10728655" cy="640080"/>
+          </a:xfrm>
+          <a:prstGeom prst="rect">
+            <a:avLst/>
+          </a:prstGeom>
+          <a:noFill/>
+        </p:spPr>
+        <p:txBody>
+          <a:bodyPr wrap="square">
+            <a:spAutoFit/>
+          </a:bodyPr>
+          <a:lstStyle/>
+          <a:p>
+            <a:pPr algn="l"/>
+            <a:r>
+              <a:rPr sz="3400" b="1">
+                <a:solidFill>
+                  <a:srgbClr val="FFFFFF"/>
+                </a:solidFill>
+                <a:latin typeface="Segoe UI"/>
+              </a:rPr>
+              <a:t>Część 2: pod maską</a:t>
+            </a:r>
+          </a:p>
+        </p:txBody>
+      </p:sp>
+      <p:sp>
+        <p:nvSpPr>
+          <p:cNvPr id="4" name="TextBox 3"/>
+          <p:cNvSpPr txBox="1"/>
+          <p:nvPr/>
+        </p:nvSpPr>
+        <p:spPr>
+          <a:xfrm>
+            <a:off x="731520" y="3566160"/>
+            <a:ext cx="10728655" cy="457200"/>
+          </a:xfrm>
+          <a:prstGeom prst="rect">
+            <a:avLst/>
+          </a:prstGeom>
+          <a:noFill/>
+        </p:spPr>
+        <p:txBody>
+          <a:bodyPr wrap="square">
+            <a:spAutoFit/>
+          </a:bodyPr>
+          <a:lstStyle/>
+          <a:p>
+            <a:pPr algn="l"/>
+            <a:r>
+              <a:rPr sz="1600" b="0">
+                <a:solidFill>
+                  <a:srgbClr val="FFFFFF"/>
+                </a:solidFill>
+                <a:latin typeface="Segoe UI"/>
+              </a:rPr>
+              <a:t>słowniczek pojęć + jak NAPRAWDĘ wygląda kod i dane na każdym etapie</a:t>
+            </a:r>
+          </a:p>
+        </p:txBody>
+      </p:sp>
+    </p:spTree>
+  </p:cSld>
+  <p:clrMapOvr>
+    <a:masterClrMapping/>
+  </p:clrMapOvr>
+</p:sld>
+</file>
+
+<file path=ppt/slides/slide15.xml><?xml version="1.0" encoding="utf-8"?>
+<p:sld xmlns:a="http://schemas.openxmlformats.org/drawingml/2006/main" xmlns:p="http://schemas.openxmlformats.org/presentationml/2006/main" xmlns:r="http://schemas.openxmlformats.org/officeDocument/2006/relationships">
+  <p:cSld>
+    <p:bg>
+      <p:bgPr>
+        <a:solidFill>
+          <a:srgbClr val="F7F7F5"/>
+        </a:solidFill>
+        <a:effectLst/>
+      </p:bgPr>
+    </p:bg>
+    <p:spTree>
+      <p:nvGrpSpPr>
+        <p:cNvPr id="1" name=""/>
+        <p:cNvGrpSpPr/>
+        <p:nvPr/>
+      </p:nvGrpSpPr>
+      <p:grpSpPr/>
+      <p:sp>
+        <p:nvSpPr>
+          <p:cNvPr id="2" name="Rectangle 1"/>
+          <p:cNvSpPr/>
+          <p:nvPr/>
+        </p:nvSpPr>
+        <p:spPr>
+          <a:xfrm>
+            <a:off x="0" y="0"/>
+            <a:ext cx="12191695" cy="146304"/>
+          </a:xfrm>
+          <a:prstGeom prst="rect">
+            <a:avLst/>
+          </a:prstGeom>
+          <a:solidFill>
+            <a:srgbClr val="1F6F8B"/>
+          </a:solidFill>
+          <a:ln>
+            <a:noFill/>
+          </a:ln>
+        </p:spPr>
+        <p:style>
+          <a:lnRef idx="1">
+            <a:schemeClr val="accent1"/>
+          </a:lnRef>
+          <a:fillRef idx="3">
+            <a:schemeClr val="accent1"/>
+          </a:fillRef>
+          <a:effectRef idx="2">
+            <a:schemeClr val="accent1"/>
+          </a:effectRef>
+          <a:fontRef idx="minor">
+            <a:schemeClr val="lt1"/>
+          </a:fontRef>
+        </p:style>
+        <p:txBody>
+          <a:bodyPr rtlCol="0" anchor="ctr"/>
+          <a:lstStyle/>
+          <a:p>
+            <a:pPr algn="ctr"/>
+          </a:p>
+        </p:txBody>
+      </p:sp>
+      <p:sp>
+        <p:nvSpPr>
+          <p:cNvPr id="3" name="TextBox 2"/>
+          <p:cNvSpPr txBox="1"/>
+          <p:nvPr/>
+        </p:nvSpPr>
+        <p:spPr>
+          <a:xfrm>
+            <a:off x="457200" y="256032"/>
+            <a:ext cx="11277295" cy="566928"/>
+          </a:xfrm>
+          <a:prstGeom prst="rect">
+            <a:avLst/>
+          </a:prstGeom>
+          <a:noFill/>
+        </p:spPr>
+        <p:txBody>
+          <a:bodyPr wrap="square">
+            <a:spAutoFit/>
+          </a:bodyPr>
+          <a:lstStyle/>
+          <a:p>
+            <a:pPr algn="l"/>
+            <a:r>
+              <a:rPr sz="2600" b="1">
+                <a:solidFill>
+                  <a:srgbClr val="1F6F8B"/>
+                </a:solidFill>
+                <a:latin typeface="Segoe UI"/>
+              </a:rPr>
+              <a:t>Słowniczek 1 — klocki AWS, których używamy</a:t>
+            </a:r>
+          </a:p>
+        </p:txBody>
+      </p:sp>
+      <p:sp>
+        <p:nvSpPr>
+          <p:cNvPr id="4" name="TextBox 3"/>
+          <p:cNvSpPr txBox="1"/>
+          <p:nvPr/>
+        </p:nvSpPr>
+        <p:spPr>
+          <a:xfrm>
+            <a:off x="548640" y="1371600"/>
+            <a:ext cx="2834640" cy="740664"/>
+          </a:xfrm>
+          <a:prstGeom prst="rect">
+            <a:avLst/>
+          </a:prstGeom>
+          <a:noFill/>
+        </p:spPr>
+        <p:txBody>
+          <a:bodyPr wrap="square">
+            <a:spAutoFit/>
+          </a:bodyPr>
+          <a:lstStyle/>
+          <a:p>
+            <a:pPr algn="l"/>
+            <a:r>
+              <a:rPr sz="1500" b="1">
+                <a:solidFill>
+                  <a:srgbClr val="1A1A2E"/>
+                </a:solidFill>
+                <a:latin typeface="Segoe UI"/>
+              </a:rPr>
+              <a:t>S3</a:t>
+            </a:r>
+          </a:p>
+        </p:txBody>
+      </p:sp>
+      <p:sp>
+        <p:nvSpPr>
+          <p:cNvPr id="5" name="TextBox 4"/>
+          <p:cNvSpPr txBox="1"/>
+          <p:nvPr/>
+        </p:nvSpPr>
+        <p:spPr>
+          <a:xfrm>
+            <a:off x="3520440" y="1371600"/>
+            <a:ext cx="8138160" cy="740664"/>
+          </a:xfrm>
+          <a:prstGeom prst="rect">
+            <a:avLst/>
+          </a:prstGeom>
+          <a:noFill/>
+        </p:spPr>
+        <p:txBody>
+          <a:bodyPr wrap="square">
+            <a:spAutoFit/>
+          </a:bodyPr>
+          <a:lstStyle/>
+          <a:p>
+            <a:pPr algn="l"/>
+            <a:r>
+              <a:rPr sz="1300" b="0">
+                <a:solidFill>
+                  <a:srgbClr val="6B6B7B"/>
+                </a:solidFill>
+                <a:latin typeface="Segoe UI"/>
+              </a:rPr>
+              <a:t>magazyn plików w chmurze; bucket = „dysk”, prefix = „folder”. U nas 3 buckety: bronze / silver / gold</a:t>
+            </a:r>
+          </a:p>
+        </p:txBody>
+      </p:sp>
+      <p:sp>
+        <p:nvSpPr>
+          <p:cNvPr id="6" name="TextBox 5"/>
+          <p:cNvSpPr txBox="1"/>
+          <p:nvPr/>
+        </p:nvSpPr>
+        <p:spPr>
+          <a:xfrm>
+            <a:off x="548640" y="2148840"/>
+            <a:ext cx="2834640" cy="740664"/>
+          </a:xfrm>
+          <a:prstGeom prst="rect">
+            <a:avLst/>
+          </a:prstGeom>
+          <a:noFill/>
+        </p:spPr>
+        <p:txBody>
+          <a:bodyPr wrap="square">
+            <a:spAutoFit/>
+          </a:bodyPr>
+          <a:lstStyle/>
+          <a:p>
+            <a:pPr algn="l"/>
+            <a:r>
+              <a:rPr sz="1500" b="1">
+                <a:solidFill>
+                  <a:srgbClr val="1A1A2E"/>
+                </a:solidFill>
+                <a:latin typeface="Segoe UI"/>
+              </a:rPr>
+              <a:t>Glue Data Catalog</a:t>
+            </a:r>
+          </a:p>
+        </p:txBody>
+      </p:sp>
+      <p:sp>
+        <p:nvSpPr>
+          <p:cNvPr id="7" name="TextBox 6"/>
+          <p:cNvSpPr txBox="1"/>
+          <p:nvPr/>
+        </p:nvSpPr>
+        <p:spPr>
+          <a:xfrm>
+            <a:off x="3520440" y="2148840"/>
+            <a:ext cx="8138160" cy="740664"/>
+          </a:xfrm>
+          <a:prstGeom prst="rect">
+            <a:avLst/>
+          </a:prstGeom>
+          <a:noFill/>
+        </p:spPr>
+        <p:txBody>
+          <a:bodyPr wrap="square">
+            <a:spAutoFit/>
+          </a:bodyPr>
+          <a:lstStyle/>
+          <a:p>
+            <a:pPr algn="l"/>
+            <a:r>
+              <a:rPr sz="1300" b="0">
+                <a:solidFill>
+                  <a:srgbClr val="6B6B7B"/>
+                </a:solidFill>
+                <a:latin typeface="Segoe UI"/>
+              </a:rPr>
+              <a:t>spis tabel: jakie kolumny, typy, gdzie pliki na S3. Sam w sobie NIE trzyma danych — tylko metadane</a:t>
+            </a:r>
+          </a:p>
+        </p:txBody>
+      </p:sp>
+      <p:sp>
+        <p:nvSpPr>
+          <p:cNvPr id="8" name="TextBox 7"/>
+          <p:cNvSpPr txBox="1"/>
+          <p:nvPr/>
+        </p:nvSpPr>
+        <p:spPr>
+          <a:xfrm>
+            <a:off x="548640" y="2926080"/>
+            <a:ext cx="2834640" cy="740664"/>
+          </a:xfrm>
+          <a:prstGeom prst="rect">
+            <a:avLst/>
+          </a:prstGeom>
+          <a:noFill/>
+        </p:spPr>
+        <p:txBody>
+          <a:bodyPr wrap="square">
+            <a:spAutoFit/>
+          </a:bodyPr>
+          <a:lstStyle/>
+          <a:p>
+            <a:pPr algn="l"/>
+            <a:r>
+              <a:rPr sz="1500" b="1">
+                <a:solidFill>
+                  <a:srgbClr val="1A1A2E"/>
+                </a:solidFill>
+                <a:latin typeface="Segoe UI"/>
+              </a:rPr>
+              <a:t>Glue Crawler</a:t>
+            </a:r>
+          </a:p>
+        </p:txBody>
+      </p:sp>
+      <p:sp>
+        <p:nvSpPr>
+          <p:cNvPr id="9" name="TextBox 8"/>
+          <p:cNvSpPr txBox="1"/>
+          <p:nvPr/>
+        </p:nvSpPr>
+        <p:spPr>
+          <a:xfrm>
+            <a:off x="3520440" y="2926080"/>
+            <a:ext cx="8138160" cy="740664"/>
+          </a:xfrm>
+          <a:prstGeom prst="rect">
+            <a:avLst/>
+          </a:prstGeom>
+          <a:noFill/>
+        </p:spPr>
+        <p:txBody>
+          <a:bodyPr wrap="square">
+            <a:spAutoFit/>
+          </a:bodyPr>
+          <a:lstStyle/>
+          <a:p>
+            <a:pPr algn="l"/>
+            <a:r>
+              <a:rPr sz="1300" b="0">
+                <a:solidFill>
+                  <a:srgbClr val="6B6B7B"/>
+                </a:solidFill>
+                <a:latin typeface="Segoe UI"/>
+              </a:rPr>
+              <a:t>robot: skanuje pliki na S3 i aktualizuje katalog (nowe partycje, schemat)</a:t>
+            </a:r>
+          </a:p>
+        </p:txBody>
+      </p:sp>
+      <p:sp>
+        <p:nvSpPr>
+          <p:cNvPr id="10" name="TextBox 9"/>
+          <p:cNvSpPr txBox="1"/>
+          <p:nvPr/>
+        </p:nvSpPr>
+        <p:spPr>
+          <a:xfrm>
+            <a:off x="548640" y="3703320"/>
+            <a:ext cx="2834640" cy="740664"/>
+          </a:xfrm>
+          <a:prstGeom prst="rect">
+            <a:avLst/>
+          </a:prstGeom>
+          <a:noFill/>
+        </p:spPr>
+        <p:txBody>
+          <a:bodyPr wrap="square">
+            <a:spAutoFit/>
+          </a:bodyPr>
+          <a:lstStyle/>
+          <a:p>
+            <a:pPr algn="l"/>
+            <a:r>
+              <a:rPr sz="1500" b="1">
+                <a:solidFill>
+                  <a:srgbClr val="1A1A2E"/>
+                </a:solidFill>
+                <a:latin typeface="Segoe UI"/>
+              </a:rPr>
+              <a:t>Glue Job (Spark)</a:t>
+            </a:r>
+          </a:p>
+        </p:txBody>
+      </p:sp>
+      <p:sp>
+        <p:nvSpPr>
+          <p:cNvPr id="11" name="TextBox 10"/>
+          <p:cNvSpPr txBox="1"/>
+          <p:nvPr/>
+        </p:nvSpPr>
+        <p:spPr>
+          <a:xfrm>
+            <a:off x="3520440" y="3703320"/>
+            <a:ext cx="8138160" cy="740664"/>
+          </a:xfrm>
+          <a:prstGeom prst="rect">
+            <a:avLst/>
+          </a:prstGeom>
+          <a:noFill/>
+        </p:spPr>
+        <p:txBody>
+          <a:bodyPr wrap="square">
+            <a:spAutoFit/>
+          </a:bodyPr>
+          <a:lstStyle/>
+          <a:p>
+            <a:pPr algn="l"/>
+            <a:r>
+              <a:rPr sz="1300" b="0">
+                <a:solidFill>
+                  <a:srgbClr val="6B6B7B"/>
+                </a:solidFill>
+                <a:latin typeface="Segoe UI"/>
+              </a:rPr>
+              <a:t>zarządzany Spark: AWS stawia klaster, puszcza nasz skrypt, gasi. Płacimy za minuty</a:t>
+            </a:r>
+          </a:p>
+        </p:txBody>
+      </p:sp>
+      <p:sp>
+        <p:nvSpPr>
+          <p:cNvPr id="12" name="TextBox 11"/>
+          <p:cNvSpPr txBox="1"/>
+          <p:nvPr/>
+        </p:nvSpPr>
+        <p:spPr>
+          <a:xfrm>
+            <a:off x="548640" y="4480560"/>
+            <a:ext cx="2834640" cy="740664"/>
+          </a:xfrm>
+          <a:prstGeom prst="rect">
+            <a:avLst/>
+          </a:prstGeom>
+          <a:noFill/>
+        </p:spPr>
+        <p:txBody>
+          <a:bodyPr wrap="square">
+            <a:spAutoFit/>
+          </a:bodyPr>
+          <a:lstStyle/>
+          <a:p>
+            <a:pPr algn="l"/>
+            <a:r>
+              <a:rPr sz="1500" b="1">
+                <a:solidFill>
+                  <a:srgbClr val="1A1A2E"/>
+                </a:solidFill>
+                <a:latin typeface="Segoe UI"/>
+              </a:rPr>
+              <a:t>Athena</a:t>
+            </a:r>
+          </a:p>
+        </p:txBody>
+      </p:sp>
+      <p:sp>
+        <p:nvSpPr>
+          <p:cNvPr id="13" name="TextBox 12"/>
+          <p:cNvSpPr txBox="1"/>
+          <p:nvPr/>
+        </p:nvSpPr>
+        <p:spPr>
+          <a:xfrm>
+            <a:off x="3520440" y="4480560"/>
+            <a:ext cx="8138160" cy="740664"/>
+          </a:xfrm>
+          <a:prstGeom prst="rect">
+            <a:avLst/>
+          </a:prstGeom>
+          <a:noFill/>
+        </p:spPr>
+        <p:txBody>
+          <a:bodyPr wrap="square">
+            <a:spAutoFit/>
+          </a:bodyPr>
+          <a:lstStyle/>
+          <a:p>
+            <a:pPr algn="l"/>
+            <a:r>
+              <a:rPr sz="1300" b="0">
+                <a:solidFill>
+                  <a:srgbClr val="6B6B7B"/>
+                </a:solidFill>
+                <a:latin typeface="Segoe UI"/>
+              </a:rPr>
+              <a:t>silnik SQL, który czyta pliki PROSTO z S3 (przez katalog Glue). Bez serwera bazy danych — płacimy za przeskanowane dane</a:t>
+            </a:r>
+          </a:p>
+        </p:txBody>
+      </p:sp>
+      <p:sp>
+        <p:nvSpPr>
+          <p:cNvPr id="14" name="TextBox 13"/>
+          <p:cNvSpPr txBox="1"/>
+          <p:nvPr/>
+        </p:nvSpPr>
+        <p:spPr>
+          <a:xfrm>
+            <a:off x="548640" y="5257800"/>
+            <a:ext cx="2834640" cy="740664"/>
+          </a:xfrm>
+          <a:prstGeom prst="rect">
+            <a:avLst/>
+          </a:prstGeom>
+          <a:noFill/>
+        </p:spPr>
+        <p:txBody>
+          <a:bodyPr wrap="square">
+            <a:spAutoFit/>
+          </a:bodyPr>
+          <a:lstStyle/>
+          <a:p>
+            <a:pPr algn="l"/>
+            <a:r>
+              <a:rPr sz="1500" b="1">
+                <a:solidFill>
+                  <a:srgbClr val="1A1A2E"/>
+                </a:solidFill>
+                <a:latin typeface="Segoe UI"/>
+              </a:rPr>
+              <a:t>Airflow</a:t>
+            </a:r>
+          </a:p>
+        </p:txBody>
+      </p:sp>
+      <p:sp>
+        <p:nvSpPr>
+          <p:cNvPr id="15" name="TextBox 14"/>
+          <p:cNvSpPr txBox="1"/>
+          <p:nvPr/>
+        </p:nvSpPr>
+        <p:spPr>
+          <a:xfrm>
+            <a:off x="3520440" y="5257800"/>
+            <a:ext cx="8138160" cy="740664"/>
+          </a:xfrm>
+          <a:prstGeom prst="rect">
+            <a:avLst/>
+          </a:prstGeom>
+          <a:noFill/>
+        </p:spPr>
+        <p:txBody>
+          <a:bodyPr wrap="square">
+            <a:spAutoFit/>
+          </a:bodyPr>
+          <a:lstStyle/>
+          <a:p>
+            <a:pPr algn="l"/>
+            <a:r>
+              <a:rPr sz="1300" b="0">
+                <a:solidFill>
+                  <a:srgbClr val="6B6B7B"/>
+                </a:solidFill>
+                <a:latin typeface="Segoe UI"/>
+              </a:rPr>
+              <a:t>orkiestrator: harmonogram + kolejność tasków + logi + retry. Sam NIC nie liczy — deleguje do Glue/Athena</a:t>
+            </a:r>
+          </a:p>
+        </p:txBody>
+      </p:sp>
+    </p:spTree>
+  </p:cSld>
+  <p:clrMapOvr>
+    <a:masterClrMapping/>
+  </p:clrMapOvr>
+</p:sld>
+</file>
+
+<file path=ppt/slides/slide16.xml><?xml version="1.0" encoding="utf-8"?>
+<p:sld xmlns:a="http://schemas.openxmlformats.org/drawingml/2006/main" xmlns:p="http://schemas.openxmlformats.org/presentationml/2006/main" xmlns:r="http://schemas.openxmlformats.org/officeDocument/2006/relationships">
+  <p:cSld>
+    <p:bg>
+      <p:bgPr>
+        <a:solidFill>
+          <a:srgbClr val="F7F7F5"/>
+        </a:solidFill>
+        <a:effectLst/>
+      </p:bgPr>
+    </p:bg>
+    <p:spTree>
+      <p:nvGrpSpPr>
+        <p:cNvPr id="1" name=""/>
+        <p:cNvGrpSpPr/>
+        <p:nvPr/>
+      </p:nvGrpSpPr>
+      <p:grpSpPr/>
+      <p:sp>
+        <p:nvSpPr>
+          <p:cNvPr id="2" name="Rectangle 1"/>
+          <p:cNvSpPr/>
+          <p:nvPr/>
+        </p:nvSpPr>
+        <p:spPr>
+          <a:xfrm>
+            <a:off x="0" y="0"/>
+            <a:ext cx="12191695" cy="146304"/>
+          </a:xfrm>
+          <a:prstGeom prst="rect">
+            <a:avLst/>
+          </a:prstGeom>
+          <a:solidFill>
+            <a:srgbClr val="1F6F8B"/>
+          </a:solidFill>
+          <a:ln>
+            <a:noFill/>
+          </a:ln>
+        </p:spPr>
+        <p:style>
+          <a:lnRef idx="1">
+            <a:schemeClr val="accent1"/>
+          </a:lnRef>
+          <a:fillRef idx="3">
+            <a:schemeClr val="accent1"/>
+          </a:fillRef>
+          <a:effectRef idx="2">
+            <a:schemeClr val="accent1"/>
+          </a:effectRef>
+          <a:fontRef idx="minor">
+            <a:schemeClr val="lt1"/>
+          </a:fontRef>
+        </p:style>
+        <p:txBody>
+          <a:bodyPr rtlCol="0" anchor="ctr"/>
+          <a:lstStyle/>
+          <a:p>
+            <a:pPr algn="ctr"/>
+          </a:p>
+        </p:txBody>
+      </p:sp>
+      <p:sp>
+        <p:nvSpPr>
+          <p:cNvPr id="3" name="TextBox 2"/>
+          <p:cNvSpPr txBox="1"/>
+          <p:nvPr/>
+        </p:nvSpPr>
+        <p:spPr>
+          <a:xfrm>
+            <a:off x="457200" y="256032"/>
+            <a:ext cx="11277295" cy="566928"/>
+          </a:xfrm>
+          <a:prstGeom prst="rect">
+            <a:avLst/>
+          </a:prstGeom>
+          <a:noFill/>
+        </p:spPr>
+        <p:txBody>
+          <a:bodyPr wrap="square">
+            <a:spAutoFit/>
+          </a:bodyPr>
+          <a:lstStyle/>
+          <a:p>
+            <a:pPr algn="l"/>
+            <a:r>
+              <a:rPr sz="2600" b="1">
+                <a:solidFill>
+                  <a:srgbClr val="1F6F8B"/>
+                </a:solidFill>
+                <a:latin typeface="Segoe UI"/>
+              </a:rPr>
+              <a:t>Słowniczek 2 — CSV vs Parquet</a:t>
+            </a:r>
+          </a:p>
+        </p:txBody>
+      </p:sp>
+      <p:sp>
+        <p:nvSpPr>
+          <p:cNvPr id="4" name="TextBox 3"/>
+          <p:cNvSpPr txBox="1"/>
+          <p:nvPr/>
+        </p:nvSpPr>
+        <p:spPr>
+          <a:xfrm>
+            <a:off x="457200" y="804672"/>
+            <a:ext cx="11277295" cy="347472"/>
+          </a:xfrm>
+          <a:prstGeom prst="rect">
+            <a:avLst/>
+          </a:prstGeom>
+          <a:noFill/>
+        </p:spPr>
+        <p:txBody>
+          <a:bodyPr wrap="square">
+            <a:spAutoFit/>
+          </a:bodyPr>
+          <a:lstStyle/>
+          <a:p>
+            <a:pPr algn="l"/>
+            <a:r>
+              <a:rPr sz="1300" b="0">
+                <a:solidFill>
+                  <a:srgbClr val="6B6B7B"/>
+                </a:solidFill>
+                <a:latin typeface="Segoe UI"/>
+              </a:rPr>
+              <a:t>dlaczego silver/gold trzymamy w Parquet, a nie CSV</a:t>
+            </a:r>
+          </a:p>
+        </p:txBody>
+      </p:sp>
+      <p:sp>
+        <p:nvSpPr>
+          <p:cNvPr id="5" name="Rectangle 4"/>
+          <p:cNvSpPr/>
+          <p:nvPr/>
+        </p:nvSpPr>
+        <p:spPr>
+          <a:xfrm>
+            <a:off x="548640" y="1325880"/>
+            <a:ext cx="5577840" cy="2377440"/>
+          </a:xfrm>
+          <a:prstGeom prst="rect">
+            <a:avLst/>
+          </a:prstGeom>
+          <a:solidFill>
+            <a:srgbClr val="FFFFFF"/>
+          </a:solidFill>
+          <a:ln w="12700">
+            <a:solidFill>
+              <a:srgbClr val="1F6F8B"/>
+            </a:solidFill>
+          </a:ln>
+        </p:spPr>
+        <p:style>
+          <a:lnRef idx="1">
+            <a:schemeClr val="accent1"/>
+          </a:lnRef>
+          <a:fillRef idx="3">
+            <a:schemeClr val="accent1"/>
+          </a:fillRef>
+          <a:effectRef idx="2">
+            <a:schemeClr val="accent1"/>
+          </a:effectRef>
+          <a:fontRef idx="minor">
+            <a:schemeClr val="lt1"/>
+          </a:fontRef>
+        </p:style>
+        <p:txBody>
+          <a:bodyPr rtlCol="0" anchor="ctr"/>
+          <a:lstStyle/>
+          <a:p>
+            <a:pPr algn="ctr"/>
+          </a:p>
+        </p:txBody>
+      </p:sp>
+      <p:sp>
+        <p:nvSpPr>
+          <p:cNvPr id="6" name="TextBox 5"/>
+          <p:cNvSpPr txBox="1"/>
+          <p:nvPr/>
+        </p:nvSpPr>
+        <p:spPr>
+          <a:xfrm>
+            <a:off x="685800" y="1399032"/>
+            <a:ext cx="5303520" cy="292608"/>
+          </a:xfrm>
+          <a:prstGeom prst="rect">
+            <a:avLst/>
+          </a:prstGeom>
+          <a:noFill/>
+        </p:spPr>
+        <p:txBody>
+          <a:bodyPr wrap="square">
+            <a:spAutoFit/>
+          </a:bodyPr>
+          <a:lstStyle/>
+          <a:p>
+            <a:pPr algn="l"/>
+            <a:r>
+              <a:rPr sz="1200" b="1">
+                <a:solidFill>
+                  <a:srgbClr val="1F6F8B"/>
+                </a:solidFill>
+                <a:latin typeface="Segoe UI"/>
+              </a:rPr>
+              <a:t>bronze: CSV</a:t>
+            </a:r>
+          </a:p>
+        </p:txBody>
+      </p:sp>
+      <p:sp>
+        <p:nvSpPr>
+          <p:cNvPr id="7" name="TextBox 6"/>
+          <p:cNvSpPr txBox="1"/>
+          <p:nvPr/>
+        </p:nvSpPr>
+        <p:spPr>
+          <a:xfrm>
+            <a:off x="685800" y="1728216"/>
+            <a:ext cx="5303520" cy="1920240"/>
+          </a:xfrm>
+          <a:prstGeom prst="rect">
+            <a:avLst/>
+          </a:prstGeom>
+          <a:noFill/>
+        </p:spPr>
+        <p:txBody>
+          <a:bodyPr wrap="square">
+            <a:spAutoFit/>
+          </a:bodyPr>
+          <a:lstStyle/>
+          <a:p>
+            <a:pPr algn="l"/>
+            <a:r>
+              <a:rPr sz="1200" b="0">
+                <a:solidFill>
+                  <a:srgbClr val="1A1A2E"/>
+                </a:solidFill>
+                <a:latin typeface="Consolas"/>
+              </a:rPr>
+              <a:t>CSV (wierszowy, tekst):</a:t>
+            </a:r>
+          </a:p>
+          <a:p>
+            <a:pPr algn="l"/>
+            <a:r>
+              <a:rPr sz="1200" b="0">
+                <a:solidFill>
+                  <a:srgbClr val="1A1A2E"/>
+                </a:solidFill>
+                <a:latin typeface="Consolas"/>
+              </a:rPr>
+              <a:t>id,data,kraj,ofiary</a:t>
+            </a:r>
+          </a:p>
+          <a:p>
+            <a:pPr algn="l"/>
+            <a:r>
+              <a:rPr sz="1200" b="0">
+                <a:solidFill>
+                  <a:srgbClr val="1A1A2E"/>
+                </a:solidFill>
+                <a:latin typeface="Consolas"/>
+              </a:rPr>
+              <a:t>YEM1,2025-07-04,Yemen,3</a:t>
+            </a:r>
+          </a:p>
+          <a:p>
+            <a:pPr algn="l"/>
+            <a:r>
+              <a:rPr sz="1200" b="0">
+                <a:solidFill>
+                  <a:srgbClr val="1A1A2E"/>
+                </a:solidFill>
+                <a:latin typeface="Consolas"/>
+              </a:rPr>
+              <a:t>YEM2,2025-07-04,Yemen,0</a:t>
+            </a:r>
+          </a:p>
+          <a:p>
+            <a:pPr algn="l"/>
+          </a:p>
+          <a:p>
+            <a:pPr algn="l"/>
+            <a:r>
+              <a:rPr sz="1200" b="0">
+                <a:solidFill>
+                  <a:srgbClr val="1A1A2E"/>
+                </a:solidFill>
+                <a:latin typeface="Consolas"/>
+              </a:rPr>
+              <a:t>wszystko to TEKST — '3' to znak,</a:t>
+            </a:r>
+          </a:p>
+          <a:p>
+            <a:pPr algn="l"/>
+            <a:r>
+              <a:rPr sz="1200" b="0">
+                <a:solidFill>
+                  <a:srgbClr val="1A1A2E"/>
+                </a:solidFill>
+                <a:latin typeface="Consolas"/>
+              </a:rPr>
+              <a:t>typy zgaduje czytający</a:t>
+            </a:r>
+          </a:p>
+        </p:txBody>
+      </p:sp>
+      <p:sp>
+        <p:nvSpPr>
+          <p:cNvPr id="8" name="Rectangle 7"/>
+          <p:cNvSpPr/>
+          <p:nvPr/>
+        </p:nvSpPr>
+        <p:spPr>
+          <a:xfrm>
+            <a:off x="6309360" y="1325880"/>
+            <a:ext cx="5394960" cy="2377440"/>
+          </a:xfrm>
+          <a:prstGeom prst="rect">
+            <a:avLst/>
+          </a:prstGeom>
+          <a:solidFill>
+            <a:srgbClr val="FFFFFF"/>
+          </a:solidFill>
+          <a:ln w="12700">
+            <a:solidFill>
+              <a:srgbClr val="1F6F8B"/>
+            </a:solidFill>
+          </a:ln>
+        </p:spPr>
+        <p:style>
+          <a:lnRef idx="1">
+            <a:schemeClr val="accent1"/>
+          </a:lnRef>
+          <a:fillRef idx="3">
+            <a:schemeClr val="accent1"/>
+          </a:fillRef>
+          <a:effectRef idx="2">
+            <a:schemeClr val="accent1"/>
+          </a:effectRef>
+          <a:fontRef idx="minor">
+            <a:schemeClr val="lt1"/>
+          </a:fontRef>
+        </p:style>
+        <p:txBody>
+          <a:bodyPr rtlCol="0" anchor="ctr"/>
+          <a:lstStyle/>
+          <a:p>
+            <a:pPr algn="ctr"/>
+          </a:p>
+        </p:txBody>
+      </p:sp>
+      <p:sp>
+        <p:nvSpPr>
+          <p:cNvPr id="9" name="TextBox 8"/>
+          <p:cNvSpPr txBox="1"/>
+          <p:nvPr/>
+        </p:nvSpPr>
+        <p:spPr>
+          <a:xfrm>
+            <a:off x="6446520" y="1399032"/>
+            <a:ext cx="5120640" cy="292608"/>
+          </a:xfrm>
+          <a:prstGeom prst="rect">
+            <a:avLst/>
+          </a:prstGeom>
+          <a:noFill/>
+        </p:spPr>
+        <p:txBody>
+          <a:bodyPr wrap="square">
+            <a:spAutoFit/>
+          </a:bodyPr>
+          <a:lstStyle/>
+          <a:p>
+            <a:pPr algn="l"/>
+            <a:r>
+              <a:rPr sz="1200" b="1">
+                <a:solidFill>
+                  <a:srgbClr val="1F6F8B"/>
+                </a:solidFill>
+                <a:latin typeface="Segoe UI"/>
+              </a:rPr>
+              <a:t>silver/gold: Parquet</a:t>
+            </a:r>
+          </a:p>
+        </p:txBody>
+      </p:sp>
+      <p:sp>
+        <p:nvSpPr>
+          <p:cNvPr id="10" name="TextBox 9"/>
+          <p:cNvSpPr txBox="1"/>
+          <p:nvPr/>
+        </p:nvSpPr>
+        <p:spPr>
+          <a:xfrm>
+            <a:off x="6446520" y="1728216"/>
+            <a:ext cx="5120640" cy="1920240"/>
+          </a:xfrm>
+          <a:prstGeom prst="rect">
+            <a:avLst/>
+          </a:prstGeom>
+          <a:noFill/>
+        </p:spPr>
+        <p:txBody>
+          <a:bodyPr wrap="square">
+            <a:spAutoFit/>
+          </a:bodyPr>
+          <a:lstStyle/>
+          <a:p>
+            <a:pPr algn="l"/>
+            <a:r>
+              <a:rPr sz="1200" b="0">
+                <a:solidFill>
+                  <a:srgbClr val="1A1A2E"/>
+                </a:solidFill>
+                <a:latin typeface="Consolas"/>
+              </a:rPr>
+              <a:t>Parquet (kolumnowy, binarny):</a:t>
+            </a:r>
+          </a:p>
+          <a:p>
+            <a:pPr algn="l"/>
+            <a:r>
+              <a:rPr sz="1200" b="0">
+                <a:solidFill>
+                  <a:srgbClr val="1A1A2E"/>
+                </a:solidFill>
+                <a:latin typeface="Consolas"/>
+              </a:rPr>
+              <a:t>[kolumna id  ] YEM1 YEM2 ...</a:t>
+            </a:r>
+          </a:p>
+          <a:p>
+            <a:pPr algn="l"/>
+            <a:r>
+              <a:rPr sz="1200" b="0">
+                <a:solidFill>
+                  <a:srgbClr val="1A1A2E"/>
+                </a:solidFill>
+                <a:latin typeface="Consolas"/>
+              </a:rPr>
+              <a:t>[kolumna data] 2025-07-04 ...</a:t>
+            </a:r>
+          </a:p>
+          <a:p>
+            <a:pPr algn="l"/>
+            <a:r>
+              <a:rPr sz="1200" b="0">
+                <a:solidFill>
+                  <a:srgbClr val="1A1A2E"/>
+                </a:solidFill>
+                <a:latin typeface="Consolas"/>
+              </a:rPr>
+              <a:t>[kolumna ofiary INT] 3 0 ...</a:t>
+            </a:r>
+          </a:p>
+          <a:p>
+            <a:pPr algn="l"/>
+          </a:p>
+          <a:p>
+            <a:pPr algn="l"/>
+            <a:r>
+              <a:rPr sz="1200" b="0">
+                <a:solidFill>
+                  <a:srgbClr val="1A1A2E"/>
+                </a:solidFill>
+                <a:latin typeface="Consolas"/>
+              </a:rPr>
+              <a:t>typy WBUDOWANE w plik +</a:t>
+            </a:r>
+          </a:p>
+          <a:p>
+            <a:pPr algn="l"/>
+            <a:r>
+              <a:rPr sz="1200" b="0">
+                <a:solidFill>
+                  <a:srgbClr val="1A1A2E"/>
+                </a:solidFill>
+                <a:latin typeface="Consolas"/>
+              </a:rPr>
+              <a:t>kompresja per kolumna</a:t>
+            </a:r>
+          </a:p>
+        </p:txBody>
+      </p:sp>
+      <p:sp>
+        <p:nvSpPr>
+          <p:cNvPr id="11" name="TextBox 10"/>
+          <p:cNvSpPr txBox="1"/>
+          <p:nvPr/>
+        </p:nvSpPr>
+        <p:spPr>
+          <a:xfrm>
+            <a:off x="548640" y="3977639"/>
+            <a:ext cx="11155680" cy="667512"/>
+          </a:xfrm>
+          <a:prstGeom prst="rect">
+            <a:avLst/>
+          </a:prstGeom>
+          <a:noFill/>
+        </p:spPr>
+        <p:txBody>
+          <a:bodyPr wrap="square">
+            <a:spAutoFit/>
+          </a:bodyPr>
+          <a:lstStyle/>
+          <a:p>
+            <a:pPr algn="l"/>
+            <a:r>
+              <a:rPr sz="1400" b="1">
+                <a:solidFill>
+                  <a:srgbClr val="1F6F8B"/>
+                </a:solidFill>
+                <a:latin typeface="Segoe UI"/>
+              </a:rPr>
+              <a:t>•  zapytanie „SUM(ofiary)” czyta z Parquet TYLKO kolumnę ofiar — z CSV musi przeczytać całe pliki</a:t>
+            </a:r>
+          </a:p>
+        </p:txBody>
+      </p:sp>
+      <p:sp>
+        <p:nvSpPr>
+          <p:cNvPr id="12" name="TextBox 11"/>
+          <p:cNvSpPr txBox="1"/>
+          <p:nvPr/>
+        </p:nvSpPr>
+        <p:spPr>
+          <a:xfrm>
+            <a:off x="548640" y="4453127"/>
+            <a:ext cx="11155680" cy="667512"/>
+          </a:xfrm>
+          <a:prstGeom prst="rect">
+            <a:avLst/>
+          </a:prstGeom>
+          <a:noFill/>
+        </p:spPr>
+        <p:txBody>
+          <a:bodyPr wrap="square">
+            <a:spAutoFit/>
+          </a:bodyPr>
+          <a:lstStyle/>
+          <a:p>
+            <a:pPr algn="l"/>
+            <a:r>
+              <a:rPr sz="1400" b="0">
+                <a:solidFill>
+                  <a:srgbClr val="1A1A2E"/>
+                </a:solidFill>
+                <a:latin typeface="Segoe UI"/>
+              </a:rPr>
+              <a:t>•  Athena płaci za przeskanowane bajty → Parquet = szybciej ORAZ taniej (kompresja kolumnowa)</a:t>
+            </a:r>
+          </a:p>
+        </p:txBody>
+      </p:sp>
+      <p:sp>
+        <p:nvSpPr>
+          <p:cNvPr id="13" name="TextBox 12"/>
+          <p:cNvSpPr txBox="1"/>
+          <p:nvPr/>
+        </p:nvSpPr>
+        <p:spPr>
+          <a:xfrm>
+            <a:off x="548640" y="4928615"/>
+            <a:ext cx="11155680" cy="667512"/>
+          </a:xfrm>
+          <a:prstGeom prst="rect">
+            <a:avLst/>
+          </a:prstGeom>
+          <a:noFill/>
+        </p:spPr>
+        <p:txBody>
+          <a:bodyPr wrap="square">
+            <a:spAutoFit/>
+          </a:bodyPr>
+          <a:lstStyle/>
+          <a:p>
+            <a:pPr algn="l"/>
+            <a:r>
+              <a:rPr sz="1400" b="0">
+                <a:solidFill>
+                  <a:srgbClr val="1A1A2E"/>
+                </a:solidFill>
+                <a:latin typeface="Segoe UI"/>
+              </a:rPr>
+              <a:t>•  typy w pliku = koniec zgadywania; to zgadywanie z CSV zaniżyło nam kiedyś ofiary 7-krotnie</a:t>
+            </a:r>
+          </a:p>
+        </p:txBody>
+      </p:sp>
+      <p:sp>
+        <p:nvSpPr>
+          <p:cNvPr id="14" name="TextBox 13"/>
+          <p:cNvSpPr txBox="1"/>
+          <p:nvPr/>
+        </p:nvSpPr>
+        <p:spPr>
+          <a:xfrm>
+            <a:off x="548640" y="5404103"/>
+            <a:ext cx="11155680" cy="667512"/>
+          </a:xfrm>
+          <a:prstGeom prst="rect">
+            <a:avLst/>
+          </a:prstGeom>
+          <a:noFill/>
+        </p:spPr>
+        <p:txBody>
+          <a:bodyPr wrap="square">
+            <a:spAutoFit/>
+          </a:bodyPr>
+          <a:lstStyle/>
+          <a:p>
+            <a:pPr algn="l"/>
+            <a:r>
+              <a:rPr sz="1400" b="0">
+                <a:solidFill>
+                  <a:srgbClr val="1A1A2E"/>
+                </a:solidFill>
+                <a:latin typeface="Segoe UI"/>
+              </a:rPr>
+              <a:t>•  CSV zostaje w bronze celowo: to wierna kopia tego, co przysłało źródło</a:t>
+            </a:r>
+          </a:p>
+        </p:txBody>
+      </p:sp>
+    </p:spTree>
+  </p:cSld>
+  <p:clrMapOvr>
+    <a:masterClrMapping/>
+  </p:clrMapOvr>
+</p:sld>
+</file>
+
+<file path=ppt/slides/slide17.xml><?xml version="1.0" encoding="utf-8"?>
+<p:sld xmlns:a="http://schemas.openxmlformats.org/drawingml/2006/main" xmlns:p="http://schemas.openxmlformats.org/presentationml/2006/main" xmlns:r="http://schemas.openxmlformats.org/officeDocument/2006/relationships">
+  <p:cSld>
+    <p:bg>
+      <p:bgPr>
+        <a:solidFill>
+          <a:srgbClr val="F7F7F5"/>
+        </a:solidFill>
+        <a:effectLst/>
+      </p:bgPr>
+    </p:bg>
+    <p:spTree>
+      <p:nvGrpSpPr>
+        <p:cNvPr id="1" name=""/>
+        <p:cNvGrpSpPr/>
+        <p:nvPr/>
+      </p:nvGrpSpPr>
+      <p:grpSpPr/>
+      <p:sp>
+        <p:nvSpPr>
+          <p:cNvPr id="2" name="Rectangle 1"/>
+          <p:cNvSpPr/>
+          <p:nvPr/>
+        </p:nvSpPr>
+        <p:spPr>
+          <a:xfrm>
+            <a:off x="0" y="0"/>
+            <a:ext cx="12191695" cy="146304"/>
+          </a:xfrm>
+          <a:prstGeom prst="rect">
+            <a:avLst/>
+          </a:prstGeom>
+          <a:solidFill>
+            <a:srgbClr val="1F6F8B"/>
+          </a:solidFill>
+          <a:ln>
+            <a:noFill/>
+          </a:ln>
+        </p:spPr>
+        <p:style>
+          <a:lnRef idx="1">
+            <a:schemeClr val="accent1"/>
+          </a:lnRef>
+          <a:fillRef idx="3">
+            <a:schemeClr val="accent1"/>
+          </a:fillRef>
+          <a:effectRef idx="2">
+            <a:schemeClr val="accent1"/>
+          </a:effectRef>
+          <a:fontRef idx="minor">
+            <a:schemeClr val="lt1"/>
+          </a:fontRef>
+        </p:style>
+        <p:txBody>
+          <a:bodyPr rtlCol="0" anchor="ctr"/>
+          <a:lstStyle/>
+          <a:p>
+            <a:pPr algn="ctr"/>
+          </a:p>
+        </p:txBody>
+      </p:sp>
+      <p:sp>
+        <p:nvSpPr>
+          <p:cNvPr id="3" name="TextBox 2"/>
+          <p:cNvSpPr txBox="1"/>
+          <p:nvPr/>
+        </p:nvSpPr>
+        <p:spPr>
+          <a:xfrm>
+            <a:off x="457200" y="256032"/>
+            <a:ext cx="11277295" cy="566928"/>
+          </a:xfrm>
+          <a:prstGeom prst="rect">
+            <a:avLst/>
+          </a:prstGeom>
+          <a:noFill/>
+        </p:spPr>
+        <p:txBody>
+          <a:bodyPr wrap="square">
+            <a:spAutoFit/>
+          </a:bodyPr>
+          <a:lstStyle/>
+          <a:p>
+            <a:pPr algn="l"/>
+            <a:r>
+              <a:rPr sz="2600" b="1">
+                <a:solidFill>
+                  <a:srgbClr val="1F6F8B"/>
+                </a:solidFill>
+                <a:latin typeface="Segoe UI"/>
+              </a:rPr>
+              <a:t>Słowniczek 3 — pojęcia procesowe</a:t>
+            </a:r>
+          </a:p>
+        </p:txBody>
+      </p:sp>
+      <p:sp>
+        <p:nvSpPr>
+          <p:cNvPr id="4" name="TextBox 3"/>
+          <p:cNvSpPr txBox="1"/>
+          <p:nvPr/>
+        </p:nvSpPr>
+        <p:spPr>
+          <a:xfrm>
+            <a:off x="548640" y="1280160"/>
+            <a:ext cx="2834640" cy="585216"/>
+          </a:xfrm>
+          <a:prstGeom prst="rect">
+            <a:avLst/>
+          </a:prstGeom>
+          <a:noFill/>
+        </p:spPr>
+        <p:txBody>
+          <a:bodyPr wrap="square">
+            <a:spAutoFit/>
+          </a:bodyPr>
+          <a:lstStyle/>
+          <a:p>
+            <a:pPr algn="l"/>
+            <a:r>
+              <a:rPr sz="1500" b="1">
+                <a:solidFill>
+                  <a:srgbClr val="1A1A2E"/>
+                </a:solidFill>
+                <a:latin typeface="Segoe UI"/>
+              </a:rPr>
+              <a:t>medallion (bronze/silver/gold)</a:t>
+            </a:r>
+          </a:p>
+        </p:txBody>
+      </p:sp>
+      <p:sp>
+        <p:nvSpPr>
+          <p:cNvPr id="5" name="TextBox 4"/>
+          <p:cNvSpPr txBox="1"/>
+          <p:nvPr/>
+        </p:nvSpPr>
+        <p:spPr>
+          <a:xfrm>
+            <a:off x="3520440" y="1280160"/>
+            <a:ext cx="8138160" cy="585216"/>
+          </a:xfrm>
+          <a:prstGeom prst="rect">
+            <a:avLst/>
+          </a:prstGeom>
+          <a:noFill/>
+        </p:spPr>
+        <p:txBody>
+          <a:bodyPr wrap="square">
+            <a:spAutoFit/>
+          </a:bodyPr>
+          <a:lstStyle/>
+          <a:p>
+            <a:pPr algn="l"/>
+            <a:r>
+              <a:rPr sz="1300" b="0">
+                <a:solidFill>
+                  <a:srgbClr val="6B6B7B"/>
+                </a:solidFill>
+                <a:latin typeface="Segoe UI"/>
+              </a:rPr>
+              <a:t>architektura warstw: surowe → oczyszczone → analityczne. Każda warstwa odtwarzalna z poprzedniej</a:t>
+            </a:r>
+          </a:p>
+        </p:txBody>
+      </p:sp>
+      <p:sp>
+        <p:nvSpPr>
+          <p:cNvPr id="6" name="TextBox 5"/>
+          <p:cNvSpPr txBox="1"/>
+          <p:nvPr/>
+        </p:nvSpPr>
+        <p:spPr>
+          <a:xfrm>
+            <a:off x="548640" y="1901952"/>
+            <a:ext cx="2834640" cy="585216"/>
+          </a:xfrm>
+          <a:prstGeom prst="rect">
+            <a:avLst/>
+          </a:prstGeom>
+          <a:noFill/>
+        </p:spPr>
+        <p:txBody>
+          <a:bodyPr wrap="square">
+            <a:spAutoFit/>
+          </a:bodyPr>
+          <a:lstStyle/>
+          <a:p>
+            <a:pPr algn="l"/>
+            <a:r>
+              <a:rPr sz="1500" b="1">
+                <a:solidFill>
+                  <a:srgbClr val="1A1A2E"/>
+                </a:solidFill>
+                <a:latin typeface="Segoe UI"/>
+              </a:rPr>
+              <a:t>watermark (znacznik)</a:t>
+            </a:r>
+          </a:p>
+        </p:txBody>
+      </p:sp>
+      <p:sp>
+        <p:nvSpPr>
+          <p:cNvPr id="7" name="TextBox 6"/>
+          <p:cNvSpPr txBox="1"/>
+          <p:nvPr/>
+        </p:nvSpPr>
+        <p:spPr>
+          <a:xfrm>
+            <a:off x="3520440" y="1901952"/>
+            <a:ext cx="8138160" cy="585216"/>
+          </a:xfrm>
+          <a:prstGeom prst="rect">
+            <a:avLst/>
+          </a:prstGeom>
+          <a:noFill/>
+        </p:spPr>
+        <p:txBody>
+          <a:bodyPr wrap="square">
+            <a:spAutoFit/>
+          </a:bodyPr>
+          <a:lstStyle/>
+          <a:p>
+            <a:pPr algn="l"/>
+            <a:r>
+              <a:rPr sz="1300" b="0">
+                <a:solidFill>
+                  <a:srgbClr val="6B6B7B"/>
+                </a:solidFill>
+                <a:latin typeface="Segoe UI"/>
+              </a:rPr>
+              <a:t>zapamiętany punkt „dokąd doszliśmy” — u nas unix timestamp w pliku na S3</a:t>
+            </a:r>
+          </a:p>
+        </p:txBody>
+      </p:sp>
+      <p:sp>
+        <p:nvSpPr>
+          <p:cNvPr id="8" name="TextBox 7"/>
+          <p:cNvSpPr txBox="1"/>
+          <p:nvPr/>
+        </p:nvSpPr>
+        <p:spPr>
+          <a:xfrm>
+            <a:off x="548640" y="2523744"/>
+            <a:ext cx="2834640" cy="585216"/>
+          </a:xfrm>
+          <a:prstGeom prst="rect">
+            <a:avLst/>
+          </a:prstGeom>
+          <a:noFill/>
+        </p:spPr>
+        <p:txBody>
+          <a:bodyPr wrap="square">
+            <a:spAutoFit/>
+          </a:bodyPr>
+          <a:lstStyle/>
+          <a:p>
+            <a:pPr algn="l"/>
+            <a:r>
+              <a:rPr sz="1500" b="1">
+                <a:solidFill>
+                  <a:srgbClr val="1A1A2E"/>
+                </a:solidFill>
+                <a:latin typeface="Segoe UI"/>
+              </a:rPr>
+              <a:t>SCD typ 1</a:t>
+            </a:r>
+          </a:p>
+        </p:txBody>
+      </p:sp>
+      <p:sp>
+        <p:nvSpPr>
+          <p:cNvPr id="9" name="TextBox 8"/>
+          <p:cNvSpPr txBox="1"/>
+          <p:nvPr/>
+        </p:nvSpPr>
+        <p:spPr>
+          <a:xfrm>
+            <a:off x="3520440" y="2523744"/>
+            <a:ext cx="8138160" cy="585216"/>
+          </a:xfrm>
+          <a:prstGeom prst="rect">
+            <a:avLst/>
+          </a:prstGeom>
+          <a:noFill/>
+        </p:spPr>
+        <p:txBody>
+          <a:bodyPr wrap="square">
+            <a:spAutoFit/>
+          </a:bodyPr>
+          <a:lstStyle/>
+          <a:p>
+            <a:pPr algn="l"/>
+            <a:r>
+              <a:rPr sz="1300" b="0">
+                <a:solidFill>
+                  <a:srgbClr val="6B6B7B"/>
+                </a:solidFill>
+                <a:latin typeface="Segoe UI"/>
+              </a:rPr>
+              <a:t>Slowly Changing Dimension: nowa wersja NADPISUJE starą (bez historii zmian). Nasz dedup</a:t>
+            </a:r>
+          </a:p>
+        </p:txBody>
+      </p:sp>
+      <p:sp>
+        <p:nvSpPr>
+          <p:cNvPr id="10" name="TextBox 9"/>
+          <p:cNvSpPr txBox="1"/>
+          <p:nvPr/>
+        </p:nvSpPr>
+        <p:spPr>
+          <a:xfrm>
+            <a:off x="548640" y="3145536"/>
+            <a:ext cx="2834640" cy="585216"/>
+          </a:xfrm>
+          <a:prstGeom prst="rect">
+            <a:avLst/>
+          </a:prstGeom>
+          <a:noFill/>
+        </p:spPr>
+        <p:txBody>
+          <a:bodyPr wrap="square">
+            <a:spAutoFit/>
+          </a:bodyPr>
+          <a:lstStyle/>
+          <a:p>
+            <a:pPr algn="l"/>
+            <a:r>
+              <a:rPr sz="1500" b="1">
+                <a:solidFill>
+                  <a:srgbClr val="1A1A2E"/>
+                </a:solidFill>
+                <a:latin typeface="Segoe UI"/>
+              </a:rPr>
+              <a:t>anti-join</a:t>
+            </a:r>
+          </a:p>
+        </p:txBody>
+      </p:sp>
+      <p:sp>
+        <p:nvSpPr>
+          <p:cNvPr id="11" name="TextBox 10"/>
+          <p:cNvSpPr txBox="1"/>
+          <p:nvPr/>
+        </p:nvSpPr>
+        <p:spPr>
+          <a:xfrm>
+            <a:off x="3520440" y="3145536"/>
+            <a:ext cx="8138160" cy="585216"/>
+          </a:xfrm>
+          <a:prstGeom prst="rect">
+            <a:avLst/>
+          </a:prstGeom>
+          <a:noFill/>
+        </p:spPr>
+        <p:txBody>
+          <a:bodyPr wrap="square">
+            <a:spAutoFit/>
+          </a:bodyPr>
+          <a:lstStyle/>
+          <a:p>
+            <a:pPr algn="l"/>
+            <a:r>
+              <a:rPr sz="1300" b="0">
+                <a:solidFill>
+                  <a:srgbClr val="6B6B7B"/>
+                </a:solidFill>
+                <a:latin typeface="Segoe UI"/>
+              </a:rPr>
+              <a:t>zostaw wiersze, które NIE mają pary w drugiej tabeli — tak usuwamy zdarzenia z rejestru deletes</a:t>
+            </a:r>
+          </a:p>
+        </p:txBody>
+      </p:sp>
+      <p:sp>
+        <p:nvSpPr>
+          <p:cNvPr id="12" name="TextBox 11"/>
+          <p:cNvSpPr txBox="1"/>
+          <p:nvPr/>
+        </p:nvSpPr>
+        <p:spPr>
+          <a:xfrm>
+            <a:off x="548640" y="3767328"/>
+            <a:ext cx="2834640" cy="585216"/>
+          </a:xfrm>
+          <a:prstGeom prst="rect">
+            <a:avLst/>
+          </a:prstGeom>
+          <a:noFill/>
+        </p:spPr>
+        <p:txBody>
+          <a:bodyPr wrap="square">
+            <a:spAutoFit/>
+          </a:bodyPr>
+          <a:lstStyle/>
+          <a:p>
+            <a:pPr algn="l"/>
+            <a:r>
+              <a:rPr sz="1500" b="1">
+                <a:solidFill>
+                  <a:srgbClr val="1A1A2E"/>
+                </a:solidFill>
+                <a:latin typeface="Segoe UI"/>
+              </a:rPr>
+              <a:t>CTAS</a:t>
+            </a:r>
+          </a:p>
+        </p:txBody>
+      </p:sp>
+      <p:sp>
+        <p:nvSpPr>
+          <p:cNvPr id="13" name="TextBox 12"/>
+          <p:cNvSpPr txBox="1"/>
+          <p:nvPr/>
+        </p:nvSpPr>
+        <p:spPr>
+          <a:xfrm>
+            <a:off x="3520440" y="3767328"/>
+            <a:ext cx="8138160" cy="585216"/>
+          </a:xfrm>
+          <a:prstGeom prst="rect">
+            <a:avLst/>
+          </a:prstGeom>
+          <a:noFill/>
+        </p:spPr>
+        <p:txBody>
+          <a:bodyPr wrap="square">
+            <a:spAutoFit/>
+          </a:bodyPr>
+          <a:lstStyle/>
+          <a:p>
+            <a:pPr algn="l"/>
+            <a:r>
+              <a:rPr sz="1300" b="0">
+                <a:solidFill>
+                  <a:srgbClr val="6B6B7B"/>
+                </a:solidFill>
+                <a:latin typeface="Segoe UI"/>
+              </a:rPr>
+              <a:t>CREATE TABLE AS SELECT — jedno zapytanie tworzy tabelę Z WYNIKIEM selecta (pliki lądują na S3)</a:t>
+            </a:r>
+          </a:p>
+        </p:txBody>
+      </p:sp>
+      <p:sp>
+        <p:nvSpPr>
+          <p:cNvPr id="14" name="TextBox 13"/>
+          <p:cNvSpPr txBox="1"/>
+          <p:nvPr/>
+        </p:nvSpPr>
+        <p:spPr>
+          <a:xfrm>
+            <a:off x="548640" y="4389120"/>
+            <a:ext cx="2834640" cy="585216"/>
+          </a:xfrm>
+          <a:prstGeom prst="rect">
+            <a:avLst/>
+          </a:prstGeom>
+          <a:noFill/>
+        </p:spPr>
+        <p:txBody>
+          <a:bodyPr wrap="square">
+            <a:spAutoFit/>
+          </a:bodyPr>
+          <a:lstStyle/>
+          <a:p>
+            <a:pPr algn="l"/>
+            <a:r>
+              <a:rPr sz="1500" b="1">
+                <a:solidFill>
+                  <a:srgbClr val="1A1A2E"/>
+                </a:solidFill>
+                <a:latin typeface="Segoe UI"/>
+              </a:rPr>
+              <a:t>idempotencja</a:t>
+            </a:r>
+          </a:p>
+        </p:txBody>
+      </p:sp>
+      <p:sp>
+        <p:nvSpPr>
+          <p:cNvPr id="15" name="TextBox 14"/>
+          <p:cNvSpPr txBox="1"/>
+          <p:nvPr/>
+        </p:nvSpPr>
+        <p:spPr>
+          <a:xfrm>
+            <a:off x="3520440" y="4389120"/>
+            <a:ext cx="8138160" cy="585216"/>
+          </a:xfrm>
+          <a:prstGeom prst="rect">
+            <a:avLst/>
+          </a:prstGeom>
+          <a:noFill/>
+        </p:spPr>
+        <p:txBody>
+          <a:bodyPr wrap="square">
+            <a:spAutoFit/>
+          </a:bodyPr>
+          <a:lstStyle/>
+          <a:p>
+            <a:pPr algn="l"/>
+            <a:r>
+              <a:rPr sz="1300" b="0">
+                <a:solidFill>
+                  <a:srgbClr val="6B6B7B"/>
+                </a:solidFill>
+                <a:latin typeface="Segoe UI"/>
+              </a:rPr>
+              <a:t>operacja puszczona N razy daje ten sam wynik co raz. U nas: DROP + wyczyść S3 + CREATE</a:t>
+            </a:r>
+          </a:p>
+        </p:txBody>
+      </p:sp>
+      <p:sp>
+        <p:nvSpPr>
+          <p:cNvPr id="16" name="TextBox 15"/>
+          <p:cNvSpPr txBox="1"/>
+          <p:nvPr/>
+        </p:nvSpPr>
+        <p:spPr>
+          <a:xfrm>
+            <a:off x="548640" y="5010912"/>
+            <a:ext cx="2834640" cy="585216"/>
+          </a:xfrm>
+          <a:prstGeom prst="rect">
+            <a:avLst/>
+          </a:prstGeom>
+          <a:noFill/>
+        </p:spPr>
+        <p:txBody>
+          <a:bodyPr wrap="square">
+            <a:spAutoFit/>
+          </a:bodyPr>
+          <a:lstStyle/>
+          <a:p>
+            <a:pPr algn="l"/>
+            <a:r>
+              <a:rPr sz="1500" b="1">
+                <a:solidFill>
+                  <a:srgbClr val="1A1A2E"/>
+                </a:solidFill>
+                <a:latin typeface="Segoe UI"/>
+              </a:rPr>
+              <a:t>ShortCircuit</a:t>
+            </a:r>
+          </a:p>
+        </p:txBody>
+      </p:sp>
+      <p:sp>
+        <p:nvSpPr>
+          <p:cNvPr id="17" name="TextBox 16"/>
+          <p:cNvSpPr txBox="1"/>
+          <p:nvPr/>
+        </p:nvSpPr>
+        <p:spPr>
+          <a:xfrm>
+            <a:off x="3520440" y="5010912"/>
+            <a:ext cx="8138160" cy="585216"/>
+          </a:xfrm>
+          <a:prstGeom prst="rect">
+            <a:avLst/>
+          </a:prstGeom>
+          <a:noFill/>
+        </p:spPr>
+        <p:txBody>
+          <a:bodyPr wrap="square">
+            <a:spAutoFit/>
+          </a:bodyPr>
+          <a:lstStyle/>
+          <a:p>
+            <a:pPr algn="l"/>
+            <a:r>
+              <a:rPr sz="1300" b="0">
+                <a:solidFill>
+                  <a:srgbClr val="6B6B7B"/>
+                </a:solidFill>
+                <a:latin typeface="Segoe UI"/>
+              </a:rPr>
+              <a:t>task-bramka w Airflow: warunek fałszywy → pomija resztę DAG-a</a:t>
+            </a:r>
+          </a:p>
+        </p:txBody>
+      </p:sp>
+      <p:sp>
+        <p:nvSpPr>
+          <p:cNvPr id="18" name="TextBox 17"/>
+          <p:cNvSpPr txBox="1"/>
+          <p:nvPr/>
+        </p:nvSpPr>
+        <p:spPr>
+          <a:xfrm>
+            <a:off x="548640" y="5632704"/>
+            <a:ext cx="2834640" cy="585216"/>
+          </a:xfrm>
+          <a:prstGeom prst="rect">
+            <a:avLst/>
+          </a:prstGeom>
+          <a:noFill/>
+        </p:spPr>
+        <p:txBody>
+          <a:bodyPr wrap="square">
+            <a:spAutoFit/>
+          </a:bodyPr>
+          <a:lstStyle/>
+          <a:p>
+            <a:pPr algn="l"/>
+            <a:r>
+              <a:rPr sz="1500" b="1">
+                <a:solidFill>
+                  <a:srgbClr val="1A1A2E"/>
+                </a:solidFill>
+                <a:latin typeface="Segoe UI"/>
+              </a:rPr>
+              <a:t>XCom</a:t>
+            </a:r>
+          </a:p>
+        </p:txBody>
+      </p:sp>
+      <p:sp>
+        <p:nvSpPr>
+          <p:cNvPr id="19" name="TextBox 18"/>
+          <p:cNvSpPr txBox="1"/>
+          <p:nvPr/>
+        </p:nvSpPr>
+        <p:spPr>
+          <a:xfrm>
+            <a:off x="3520440" y="5632704"/>
+            <a:ext cx="8138160" cy="585216"/>
+          </a:xfrm>
+          <a:prstGeom prst="rect">
+            <a:avLst/>
+          </a:prstGeom>
+          <a:noFill/>
+        </p:spPr>
+        <p:txBody>
+          <a:bodyPr wrap="square">
+            <a:spAutoFit/>
+          </a:bodyPr>
+          <a:lstStyle/>
+          <a:p>
+            <a:pPr algn="l"/>
+            <a:r>
+              <a:rPr sz="1300" b="0">
+                <a:solidFill>
+                  <a:srgbClr val="6B6B7B"/>
+                </a:solidFill>
+                <a:latin typeface="Segoe UI"/>
+              </a:rPr>
+              <a:t>kanał między taskami Airflow: event_load przekazuje liczbę wierszy do check_new_data</a:t>
+            </a:r>
+          </a:p>
+        </p:txBody>
+      </p:sp>
+    </p:spTree>
+  </p:cSld>
+  <p:clrMapOvr>
+    <a:masterClrMapping/>
+  </p:clrMapOvr>
+</p:sld>
+</file>
+
+<file path=ppt/slides/slide18.xml><?xml version="1.0" encoding="utf-8"?>
+<p:sld xmlns:a="http://schemas.openxmlformats.org/drawingml/2006/main" xmlns:p="http://schemas.openxmlformats.org/presentationml/2006/main" xmlns:r="http://schemas.openxmlformats.org/officeDocument/2006/relationships">
+  <p:cSld>
+    <p:bg>
+      <p:bgPr>
+        <a:solidFill>
+          <a:srgbClr val="F7F7F5"/>
+        </a:solidFill>
+        <a:effectLst/>
+      </p:bgPr>
+    </p:bg>
+    <p:spTree>
+      <p:nvGrpSpPr>
+        <p:cNvPr id="1" name=""/>
+        <p:cNvGrpSpPr/>
+        <p:nvPr/>
+      </p:nvGrpSpPr>
+      <p:grpSpPr/>
+      <p:sp>
+        <p:nvSpPr>
+          <p:cNvPr id="2" name="Rectangle 1"/>
+          <p:cNvSpPr/>
+          <p:nvPr/>
+        </p:nvSpPr>
+        <p:spPr>
+          <a:xfrm>
+            <a:off x="0" y="0"/>
+            <a:ext cx="12191695" cy="146304"/>
+          </a:xfrm>
+          <a:prstGeom prst="rect">
+            <a:avLst/>
+          </a:prstGeom>
+          <a:solidFill>
+            <a:srgbClr val="1F6F8B"/>
+          </a:solidFill>
+          <a:ln>
+            <a:noFill/>
+          </a:ln>
+        </p:spPr>
+        <p:style>
+          <a:lnRef idx="1">
+            <a:schemeClr val="accent1"/>
+          </a:lnRef>
+          <a:fillRef idx="3">
+            <a:schemeClr val="accent1"/>
+          </a:fillRef>
+          <a:effectRef idx="2">
+            <a:schemeClr val="accent1"/>
+          </a:effectRef>
+          <a:fontRef idx="minor">
+            <a:schemeClr val="lt1"/>
+          </a:fontRef>
+        </p:style>
+        <p:txBody>
+          <a:bodyPr rtlCol="0" anchor="ctr"/>
+          <a:lstStyle/>
+          <a:p>
+            <a:pPr algn="ctr"/>
+          </a:p>
+        </p:txBody>
+      </p:sp>
+      <p:sp>
+        <p:nvSpPr>
+          <p:cNvPr id="3" name="TextBox 2"/>
+          <p:cNvSpPr txBox="1"/>
+          <p:nvPr/>
+        </p:nvSpPr>
+        <p:spPr>
+          <a:xfrm>
+            <a:off x="457200" y="256032"/>
+            <a:ext cx="11277295" cy="566928"/>
+          </a:xfrm>
+          <a:prstGeom prst="rect">
+            <a:avLst/>
+          </a:prstGeom>
+          <a:noFill/>
+        </p:spPr>
+        <p:txBody>
+          <a:bodyPr wrap="square">
+            <a:spAutoFit/>
+          </a:bodyPr>
+          <a:lstStyle/>
+          <a:p>
+            <a:pPr algn="l"/>
+            <a:r>
+              <a:rPr sz="2600" b="1">
+                <a:solidFill>
+                  <a:srgbClr val="1F6F8B"/>
+                </a:solidFill>
+                <a:latin typeface="Segoe UI"/>
+              </a:rPr>
+              <a:t>Pod maską: logowanie i pobór z API</a:t>
+            </a:r>
+          </a:p>
+        </p:txBody>
+      </p:sp>
+      <p:sp>
+        <p:nvSpPr>
+          <p:cNvPr id="4" name="TextBox 3"/>
+          <p:cNvSpPr txBox="1"/>
+          <p:nvPr/>
+        </p:nvSpPr>
+        <p:spPr>
+          <a:xfrm>
+            <a:off x="457200" y="804672"/>
+            <a:ext cx="11277295" cy="347472"/>
+          </a:xfrm>
+          <a:prstGeom prst="rect">
+            <a:avLst/>
+          </a:prstGeom>
+          <a:noFill/>
+        </p:spPr>
+        <p:txBody>
+          <a:bodyPr wrap="square">
+            <a:spAutoFit/>
+          </a:bodyPr>
+          <a:lstStyle/>
+          <a:p>
+            <a:pPr algn="l"/>
+            <a:r>
+              <a:rPr sz="1300" b="0">
+                <a:solidFill>
+                  <a:srgbClr val="6B6B7B"/>
+                </a:solidFill>
+                <a:latin typeface="Segoe UI"/>
+              </a:rPr>
+              <a:t>OAuth 2.0 password grant — nasz main/src/client.py</a:t>
+            </a:r>
+          </a:p>
+        </p:txBody>
+      </p:sp>
+      <p:sp>
+        <p:nvSpPr>
+          <p:cNvPr id="5" name="Rectangle 4"/>
+          <p:cNvSpPr/>
+          <p:nvPr/>
+        </p:nvSpPr>
+        <p:spPr>
+          <a:xfrm>
+            <a:off x="548640" y="1325880"/>
+            <a:ext cx="11155680" cy="2286000"/>
+          </a:xfrm>
+          <a:prstGeom prst="rect">
+            <a:avLst/>
+          </a:prstGeom>
+          <a:solidFill>
+            <a:srgbClr val="FFFFFF"/>
+          </a:solidFill>
+          <a:ln w="12700">
+            <a:solidFill>
+              <a:srgbClr val="1F6F8B"/>
+            </a:solidFill>
+          </a:ln>
+        </p:spPr>
+        <p:style>
+          <a:lnRef idx="1">
+            <a:schemeClr val="accent1"/>
+          </a:lnRef>
+          <a:fillRef idx="3">
+            <a:schemeClr val="accent1"/>
+          </a:fillRef>
+          <a:effectRef idx="2">
+            <a:schemeClr val="accent1"/>
+          </a:effectRef>
+          <a:fontRef idx="minor">
+            <a:schemeClr val="lt1"/>
+          </a:fontRef>
+        </p:style>
+        <p:txBody>
+          <a:bodyPr rtlCol="0" anchor="ctr"/>
+          <a:lstStyle/>
+          <a:p>
+            <a:pPr algn="ctr"/>
+          </a:p>
+        </p:txBody>
+      </p:sp>
+      <p:sp>
+        <p:nvSpPr>
+          <p:cNvPr id="6" name="TextBox 5"/>
+          <p:cNvSpPr txBox="1"/>
+          <p:nvPr/>
+        </p:nvSpPr>
+        <p:spPr>
+          <a:xfrm>
+            <a:off x="685800" y="1399032"/>
+            <a:ext cx="10881359" cy="292608"/>
+          </a:xfrm>
+          <a:prstGeom prst="rect">
+            <a:avLst/>
+          </a:prstGeom>
+          <a:noFill/>
+        </p:spPr>
+        <p:txBody>
+          <a:bodyPr wrap="square">
+            <a:spAutoFit/>
+          </a:bodyPr>
+          <a:lstStyle/>
+          <a:p>
+            <a:pPr algn="l"/>
+            <a:r>
+              <a:rPr sz="1200" b="1">
+                <a:solidFill>
+                  <a:srgbClr val="1F6F8B"/>
+                </a:solidFill>
+                <a:latin typeface="Segoe UI"/>
+              </a:rPr>
+              <a:t>dialog z API</a:t>
+            </a:r>
+          </a:p>
+        </p:txBody>
+      </p:sp>
+      <p:sp>
+        <p:nvSpPr>
+          <p:cNvPr id="7" name="TextBox 6"/>
+          <p:cNvSpPr txBox="1"/>
+          <p:nvPr/>
+        </p:nvSpPr>
+        <p:spPr>
+          <a:xfrm>
+            <a:off x="685800" y="1728216"/>
+            <a:ext cx="10881359" cy="1828800"/>
+          </a:xfrm>
+          <a:prstGeom prst="rect">
+            <a:avLst/>
+          </a:prstGeom>
+          <a:noFill/>
+        </p:spPr>
+        <p:txBody>
+          <a:bodyPr wrap="square">
+            <a:spAutoFit/>
+          </a:bodyPr>
+          <a:lstStyle/>
+          <a:p>
+            <a:pPr algn="l"/>
+            <a:r>
+              <a:rPr sz="1200" b="0">
+                <a:solidFill>
+                  <a:srgbClr val="1A1A2E"/>
+                </a:solidFill>
+                <a:latin typeface="Consolas"/>
+              </a:rPr>
+              <a:t>POST https://acleddata.com/oauth/token</a:t>
+            </a:r>
+          </a:p>
+          <a:p>
+            <a:pPr algn="l"/>
+            <a:r>
+              <a:rPr sz="1200" b="0">
+                <a:solidFill>
+                  <a:srgbClr val="1A1A2E"/>
+                </a:solidFill>
+                <a:latin typeface="Consolas"/>
+              </a:rPr>
+              <a:t>     username=..., password=..., grant_type=password, client_id=acled</a:t>
+            </a:r>
+          </a:p>
+          <a:p>
+            <a:pPr algn="l"/>
+            <a:r>
+              <a:rPr sz="1200" b="0">
+                <a:solidFill>
+                  <a:srgbClr val="1A1A2E"/>
+                </a:solidFill>
+                <a:latin typeface="Consolas"/>
+              </a:rPr>
+              <a:t>← {"access_token": "eyJ0eXAiOiJK...", "refresh_token": "...", "expires_in": 86400}</a:t>
+            </a:r>
+          </a:p>
+          <a:p>
+            <a:pPr algn="l"/>
+          </a:p>
+          <a:p>
+            <a:pPr algn="l"/>
+            <a:r>
+              <a:rPr sz="1200" b="0">
+                <a:solidFill>
+                  <a:srgbClr val="1A1A2E"/>
+                </a:solidFill>
+                <a:latin typeface="Consolas"/>
+              </a:rPr>
+              <a:t>GET  https://acleddata.com/api/acled/read?_format=csv&amp;page=1</a:t>
+            </a:r>
+          </a:p>
+          <a:p>
+            <a:pPr algn="l"/>
+            <a:r>
+              <a:rPr sz="1200" b="0">
+                <a:solidFill>
+                  <a:srgbClr val="1A1A2E"/>
+                </a:solidFill>
+                <a:latin typeface="Consolas"/>
+              </a:rPr>
+              <a:t>     &amp;timestamp=1783150011&amp;timestamp_where=&gt;=          ← przyrostowość!</a:t>
+            </a:r>
+          </a:p>
+          <a:p>
+            <a:pPr algn="l"/>
+            <a:r>
+              <a:rPr sz="1200" b="0">
+                <a:solidFill>
+                  <a:srgbClr val="1A1A2E"/>
+                </a:solidFill>
+                <a:latin typeface="Consolas"/>
+              </a:rPr>
+              <a:t>     nagłówek:  Authorization: Bearer eyJ0eXAiOiJK...</a:t>
+            </a:r>
+          </a:p>
+        </p:txBody>
+      </p:sp>
+      <p:sp>
+        <p:nvSpPr>
+          <p:cNvPr id="8" name="TextBox 7"/>
+          <p:cNvSpPr txBox="1"/>
+          <p:nvPr/>
+        </p:nvSpPr>
+        <p:spPr>
+          <a:xfrm>
+            <a:off x="548640" y="3840480"/>
+            <a:ext cx="11155680" cy="667512"/>
+          </a:xfrm>
+          <a:prstGeom prst="rect">
+            <a:avLst/>
+          </a:prstGeom>
+          <a:noFill/>
+        </p:spPr>
+        <p:txBody>
+          <a:bodyPr wrap="square">
+            <a:spAutoFit/>
+          </a:bodyPr>
+          <a:lstStyle/>
+          <a:p>
+            <a:pPr algn="l"/>
+            <a:r>
+              <a:rPr sz="1400" b="1">
+                <a:solidFill>
+                  <a:srgbClr val="1F6F8B"/>
+                </a:solidFill>
+                <a:latin typeface="Segoe UI"/>
+              </a:rPr>
+              <a:t>•  OAuth: hasło wymieniamy RAZ na token; potem każde zapytanie niesie token w nagłówku</a:t>
+            </a:r>
+          </a:p>
+        </p:txBody>
+      </p:sp>
+      <p:sp>
+        <p:nvSpPr>
+          <p:cNvPr id="9" name="TextBox 8"/>
+          <p:cNvSpPr txBox="1"/>
+          <p:nvPr/>
+        </p:nvSpPr>
+        <p:spPr>
+          <a:xfrm>
+            <a:off x="548640" y="4315968"/>
+            <a:ext cx="11155680" cy="667512"/>
+          </a:xfrm>
+          <a:prstGeom prst="rect">
+            <a:avLst/>
+          </a:prstGeom>
+          <a:noFill/>
+        </p:spPr>
+        <p:txBody>
+          <a:bodyPr wrap="square">
+            <a:spAutoFit/>
+          </a:bodyPr>
+          <a:lstStyle/>
+          <a:p>
+            <a:pPr algn="l"/>
+            <a:r>
+              <a:rPr sz="1400" b="0">
+                <a:solidFill>
+                  <a:srgbClr val="1A1A2E"/>
+                </a:solidFill>
+                <a:latin typeface="Segoe UI"/>
+              </a:rPr>
+              <a:t>•  token żyje 24 h; ACLED unieważnia stary przy wydaniu nowego → u nas re-login przy 401</a:t>
+            </a:r>
+          </a:p>
+        </p:txBody>
+      </p:sp>
+      <p:sp>
+        <p:nvSpPr>
+          <p:cNvPr id="10" name="TextBox 9"/>
+          <p:cNvSpPr txBox="1"/>
+          <p:nvPr/>
+        </p:nvSpPr>
+        <p:spPr>
+          <a:xfrm>
+            <a:off x="548640" y="4791456"/>
+            <a:ext cx="11155680" cy="667512"/>
+          </a:xfrm>
+          <a:prstGeom prst="rect">
+            <a:avLst/>
+          </a:prstGeom>
+          <a:noFill/>
+        </p:spPr>
+        <p:txBody>
+          <a:bodyPr wrap="square">
+            <a:spAutoFit/>
+          </a:bodyPr>
+          <a:lstStyle/>
+          <a:p>
+            <a:pPr algn="l"/>
+            <a:r>
+              <a:rPr sz="1400" b="0">
+                <a:solidFill>
+                  <a:srgbClr val="1A1A2E"/>
+                </a:solidFill>
+                <a:latin typeface="Segoe UI"/>
+              </a:rPr>
+              <a:t>•  paginacja: strony po 5 000 wierszy, pętla aż przyjdzie pusta strona</a:t>
+            </a:r>
+          </a:p>
+        </p:txBody>
+      </p:sp>
+      <p:sp>
+        <p:nvSpPr>
+          <p:cNvPr id="11" name="TextBox 10"/>
+          <p:cNvSpPr txBox="1"/>
+          <p:nvPr/>
+        </p:nvSpPr>
+        <p:spPr>
+          <a:xfrm>
+            <a:off x="548640" y="5266944"/>
+            <a:ext cx="11155680" cy="667512"/>
+          </a:xfrm>
+          <a:prstGeom prst="rect">
+            <a:avLst/>
+          </a:prstGeom>
+          <a:noFill/>
+        </p:spPr>
+        <p:txBody>
+          <a:bodyPr wrap="square">
+            <a:spAutoFit/>
+          </a:bodyPr>
+          <a:lstStyle/>
+          <a:p>
+            <a:pPr algn="l"/>
+            <a:r>
+              <a:rPr sz="1400" b="0">
+                <a:solidFill>
+                  <a:srgbClr val="1A1A2E"/>
+                </a:solidFill>
+                <a:latin typeface="Segoe UI"/>
+              </a:rPr>
+              <a:t>•  expires_in = sekundy życia tokena; Bearer = „okaziciel” — kto ma token, ten ma dostęp</a:t>
+            </a:r>
+          </a:p>
+        </p:txBody>
+      </p:sp>
+    </p:spTree>
+  </p:cSld>
+  <p:clrMapOvr>
+    <a:masterClrMapping/>
+  </p:clrMapOvr>
+</p:sld>
+</file>
+
+<file path=ppt/slides/slide19.xml><?xml version="1.0" encoding="utf-8"?>
+<p:sld xmlns:a="http://schemas.openxmlformats.org/drawingml/2006/main" xmlns:p="http://schemas.openxmlformats.org/presentationml/2006/main" xmlns:r="http://schemas.openxmlformats.org/officeDocument/2006/relationships">
+  <p:cSld>
+    <p:bg>
+      <p:bgPr>
+        <a:solidFill>
+          <a:srgbClr val="F7F7F5"/>
+        </a:solidFill>
+        <a:effectLst/>
+      </p:bgPr>
+    </p:bg>
+    <p:spTree>
+      <p:nvGrpSpPr>
+        <p:cNvPr id="1" name=""/>
+        <p:cNvGrpSpPr/>
+        <p:nvPr/>
+      </p:nvGrpSpPr>
+      <p:grpSpPr/>
+      <p:sp>
+        <p:nvSpPr>
+          <p:cNvPr id="2" name="Rectangle 1"/>
+          <p:cNvSpPr/>
+          <p:nvPr/>
+        </p:nvSpPr>
+        <p:spPr>
+          <a:xfrm>
+            <a:off x="0" y="0"/>
+            <a:ext cx="12191695" cy="146304"/>
+          </a:xfrm>
+          <a:prstGeom prst="rect">
+            <a:avLst/>
+          </a:prstGeom>
+          <a:solidFill>
+            <a:srgbClr val="1F6F8B"/>
+          </a:solidFill>
+          <a:ln>
+            <a:noFill/>
+          </a:ln>
+        </p:spPr>
+        <p:style>
+          <a:lnRef idx="1">
+            <a:schemeClr val="accent1"/>
+          </a:lnRef>
+          <a:fillRef idx="3">
+            <a:schemeClr val="accent1"/>
+          </a:fillRef>
+          <a:effectRef idx="2">
+            <a:schemeClr val="accent1"/>
+          </a:effectRef>
+          <a:fontRef idx="minor">
+            <a:schemeClr val="lt1"/>
+          </a:fontRef>
+        </p:style>
+        <p:txBody>
+          <a:bodyPr rtlCol="0" anchor="ctr"/>
+          <a:lstStyle/>
+          <a:p>
+            <a:pPr algn="ctr"/>
+          </a:p>
+        </p:txBody>
+      </p:sp>
+      <p:sp>
+        <p:nvSpPr>
+          <p:cNvPr id="3" name="TextBox 2"/>
+          <p:cNvSpPr txBox="1"/>
+          <p:nvPr/>
+        </p:nvSpPr>
+        <p:spPr>
+          <a:xfrm>
+            <a:off x="457200" y="256032"/>
+            <a:ext cx="11277295" cy="566928"/>
+          </a:xfrm>
+          <a:prstGeom prst="rect">
+            <a:avLst/>
+          </a:prstGeom>
+          <a:noFill/>
+        </p:spPr>
+        <p:txBody>
+          <a:bodyPr wrap="square">
+            <a:spAutoFit/>
+          </a:bodyPr>
+          <a:lstStyle/>
+          <a:p>
+            <a:pPr algn="l"/>
+            <a:r>
+              <a:rPr sz="2600" b="1">
+                <a:solidFill>
+                  <a:srgbClr val="1F6F8B"/>
+                </a:solidFill>
+                <a:latin typeface="Segoe UI"/>
+              </a:rPr>
+              <a:t>Pod maską: silver_transform (PySpark)</a:t>
+            </a:r>
+          </a:p>
+        </p:txBody>
+      </p:sp>
+      <p:sp>
+        <p:nvSpPr>
+          <p:cNvPr id="4" name="TextBox 3"/>
+          <p:cNvSpPr txBox="1"/>
+          <p:nvPr/>
+        </p:nvSpPr>
+        <p:spPr>
+          <a:xfrm>
+            <a:off x="457200" y="804672"/>
+            <a:ext cx="11277295" cy="347472"/>
+          </a:xfrm>
+          <a:prstGeom prst="rect">
+            <a:avLst/>
+          </a:prstGeom>
+          <a:noFill/>
+        </p:spPr>
+        <p:txBody>
+          <a:bodyPr wrap="square">
+            <a:spAutoFit/>
+          </a:bodyPr>
+          <a:lstStyle/>
+          <a:p>
+            <a:pPr algn="l"/>
+            <a:r>
+              <a:rPr sz="1300" b="0">
+                <a:solidFill>
+                  <a:srgbClr val="6B6B7B"/>
+                </a:solidFill>
+                <a:latin typeface="Segoe UI"/>
+              </a:rPr>
+              <a:t>dedup + usunięcie wycofanych + typy — sedno jobu Glue</a:t>
+            </a:r>
+          </a:p>
+        </p:txBody>
+      </p:sp>
+      <p:sp>
+        <p:nvSpPr>
+          <p:cNvPr id="5" name="Rectangle 4"/>
+          <p:cNvSpPr/>
+          <p:nvPr/>
+        </p:nvSpPr>
+        <p:spPr>
+          <a:xfrm>
+            <a:off x="548640" y="1325880"/>
+            <a:ext cx="11155680" cy="3108960"/>
+          </a:xfrm>
+          <a:prstGeom prst="rect">
+            <a:avLst/>
+          </a:prstGeom>
+          <a:solidFill>
+            <a:srgbClr val="FFFFFF"/>
+          </a:solidFill>
+          <a:ln w="12700">
+            <a:solidFill>
+              <a:srgbClr val="1F6F8B"/>
+            </a:solidFill>
+          </a:ln>
+        </p:spPr>
+        <p:style>
+          <a:lnRef idx="1">
+            <a:schemeClr val="accent1"/>
+          </a:lnRef>
+          <a:fillRef idx="3">
+            <a:schemeClr val="accent1"/>
+          </a:fillRef>
+          <a:effectRef idx="2">
+            <a:schemeClr val="accent1"/>
+          </a:effectRef>
+          <a:fontRef idx="minor">
+            <a:schemeClr val="lt1"/>
+          </a:fontRef>
+        </p:style>
+        <p:txBody>
+          <a:bodyPr rtlCol="0" anchor="ctr"/>
+          <a:lstStyle/>
+          <a:p>
+            <a:pPr algn="ctr"/>
+          </a:p>
+        </p:txBody>
+      </p:sp>
+      <p:sp>
+        <p:nvSpPr>
+          <p:cNvPr id="6" name="TextBox 5"/>
+          <p:cNvSpPr txBox="1"/>
+          <p:nvPr/>
+        </p:nvSpPr>
+        <p:spPr>
+          <a:xfrm>
+            <a:off x="685800" y="1399032"/>
+            <a:ext cx="10881359" cy="292608"/>
+          </a:xfrm>
+          <a:prstGeom prst="rect">
+            <a:avLst/>
+          </a:prstGeom>
+          <a:noFill/>
+        </p:spPr>
+        <p:txBody>
+          <a:bodyPr wrap="square">
+            <a:spAutoFit/>
+          </a:bodyPr>
+          <a:lstStyle/>
+          <a:p>
+            <a:pPr algn="l"/>
+            <a:r>
+              <a:rPr sz="1200" b="1">
+                <a:solidFill>
+                  <a:srgbClr val="1F6F8B"/>
+                </a:solidFill>
+                <a:latin typeface="Segoe UI"/>
+              </a:rPr>
+              <a:t>logika (uproszczona) — main/glue/silver_transform.py</a:t>
+            </a:r>
+          </a:p>
+        </p:txBody>
+      </p:sp>
+      <p:sp>
+        <p:nvSpPr>
+          <p:cNvPr id="7" name="TextBox 6"/>
+          <p:cNvSpPr txBox="1"/>
+          <p:nvPr/>
+        </p:nvSpPr>
+        <p:spPr>
+          <a:xfrm>
+            <a:off x="685800" y="1728216"/>
+            <a:ext cx="10881359" cy="2651760"/>
+          </a:xfrm>
+          <a:prstGeom prst="rect">
+            <a:avLst/>
+          </a:prstGeom>
+          <a:noFill/>
+        </p:spPr>
+        <p:txBody>
+          <a:bodyPr wrap="square">
+            <a:spAutoFit/>
+          </a:bodyPr>
+          <a:lstStyle/>
+          <a:p>
+            <a:pPr algn="l"/>
+            <a:r>
+              <a:rPr sz="1200" b="0">
+                <a:solidFill>
+                  <a:srgbClr val="1A1A2E"/>
+                </a:solidFill>
+                <a:latin typeface="Consolas"/>
+              </a:rPr>
+              <a:t>okno = Window.partitionBy('event_id_cnty').orderBy(desc('timestamp'))</a:t>
+            </a:r>
+          </a:p>
+          <a:p>
+            <a:pPr algn="l"/>
+            <a:r>
+              <a:rPr sz="1200" b="0">
+                <a:solidFill>
+                  <a:srgbClr val="1A1A2E"/>
+                </a:solidFill>
+                <a:latin typeface="Consolas"/>
+              </a:rPr>
+              <a:t>silver = (bronze</a:t>
+            </a:r>
+          </a:p>
+          <a:p>
+            <a:pPr algn="l"/>
+            <a:r>
+              <a:rPr sz="1200" b="0">
+                <a:solidFill>
+                  <a:srgbClr val="1A1A2E"/>
+                </a:solidFill>
+                <a:latin typeface="Consolas"/>
+              </a:rPr>
+              <a:t>   .withColumn('rn', row_number().over(okno))   # ponumeruj wersje zdarzenia</a:t>
+            </a:r>
+          </a:p>
+          <a:p>
+            <a:pPr algn="l"/>
+            <a:r>
+              <a:rPr sz="1200" b="0">
+                <a:solidFill>
+                  <a:srgbClr val="1A1A2E"/>
+                </a:solidFill>
+                <a:latin typeface="Consolas"/>
+              </a:rPr>
+              <a:t>   .filter('rn = 1')                            # zostaw najnowszą (SCD typ 1)</a:t>
+            </a:r>
+          </a:p>
+          <a:p>
+            <a:pPr algn="l"/>
+            <a:r>
+              <a:rPr sz="1200" b="0">
+                <a:solidFill>
+                  <a:srgbClr val="1A1A2E"/>
+                </a:solidFill>
+                <a:latin typeface="Consolas"/>
+              </a:rPr>
+              <a:t>   .join(deletes, 'event_id_cnty', 'left_anti') # wytnij wycofane przez ACLED</a:t>
+            </a:r>
+          </a:p>
+          <a:p>
+            <a:pPr algn="l"/>
+            <a:r>
+              <a:rPr sz="1200" b="0">
+                <a:solidFill>
+                  <a:srgbClr val="1A1A2E"/>
+                </a:solidFill>
+                <a:latin typeface="Consolas"/>
+              </a:rPr>
+              <a:t>   .withColumn('fatalities', col('fatalities').cast('int'))   # typy!</a:t>
+            </a:r>
+          </a:p>
+          <a:p>
+            <a:pPr algn="l"/>
+            <a:r>
+              <a:rPr sz="1200" b="0">
+                <a:solidFill>
+                  <a:srgbClr val="1A1A2E"/>
+                </a:solidFill>
+                <a:latin typeface="Consolas"/>
+              </a:rPr>
+              <a:t>   .withColumn('event_date', col('event_date').cast('date')))</a:t>
+            </a:r>
+          </a:p>
+          <a:p>
+            <a:pPr algn="l"/>
+            <a:r>
+              <a:rPr sz="1200" b="0">
+                <a:solidFill>
+                  <a:srgbClr val="1A1A2E"/>
+                </a:solidFill>
+                <a:latin typeface="Consolas"/>
+              </a:rPr>
+              <a:t>silver.write.mode('overwrite').parquet('s3://mw-acled-silver-dev/events/')</a:t>
+            </a:r>
+          </a:p>
+        </p:txBody>
+      </p:sp>
+      <p:sp>
+        <p:nvSpPr>
+          <p:cNvPr id="8" name="TextBox 7"/>
+          <p:cNvSpPr txBox="1"/>
+          <p:nvPr/>
+        </p:nvSpPr>
+        <p:spPr>
+          <a:xfrm>
+            <a:off x="548640" y="4663440"/>
+            <a:ext cx="11155680" cy="649224"/>
+          </a:xfrm>
+          <a:prstGeom prst="rect">
+            <a:avLst/>
+          </a:prstGeom>
+          <a:noFill/>
+        </p:spPr>
+        <p:txBody>
+          <a:bodyPr wrap="square">
+            <a:spAutoFit/>
+          </a:bodyPr>
+          <a:lstStyle/>
+          <a:p>
+            <a:pPr algn="l"/>
+            <a:r>
+              <a:rPr sz="1400" b="0">
+                <a:solidFill>
+                  <a:srgbClr val="1A1A2E"/>
+                </a:solidFill>
+                <a:latin typeface="Segoe UI"/>
+              </a:rPr>
+              <a:t>•  partitionBy = grupuj po zdarzeniu; orderBy desc = najnowsza wersja dostaje rn=1</a:t>
+            </a:r>
+          </a:p>
+        </p:txBody>
+      </p:sp>
+      <p:sp>
+        <p:nvSpPr>
+          <p:cNvPr id="9" name="TextBox 8"/>
+          <p:cNvSpPr txBox="1"/>
+          <p:nvPr/>
+        </p:nvSpPr>
+        <p:spPr>
+          <a:xfrm>
+            <a:off x="548640" y="5120640"/>
+            <a:ext cx="11155680" cy="649224"/>
+          </a:xfrm>
+          <a:prstGeom prst="rect">
+            <a:avLst/>
+          </a:prstGeom>
+          <a:noFill/>
+        </p:spPr>
+        <p:txBody>
+          <a:bodyPr wrap="square">
+            <a:spAutoFit/>
+          </a:bodyPr>
+          <a:lstStyle/>
+          <a:p>
+            <a:pPr algn="l"/>
+            <a:r>
+              <a:rPr sz="1400" b="0">
+                <a:solidFill>
+                  <a:srgbClr val="1A1A2E"/>
+                </a:solidFill>
+                <a:latin typeface="Segoe UI"/>
+              </a:rPr>
+              <a:t>•  left_anti = anti-join: zostają tylko zdarzenia BEZ pary w rejestrze deletes</a:t>
+            </a:r>
+          </a:p>
+        </p:txBody>
+      </p:sp>
+      <p:sp>
+        <p:nvSpPr>
+          <p:cNvPr id="10" name="TextBox 9"/>
+          <p:cNvSpPr txBox="1"/>
+          <p:nvPr/>
+        </p:nvSpPr>
+        <p:spPr>
+          <a:xfrm>
+            <a:off x="548640" y="5577840"/>
+            <a:ext cx="11155680" cy="649224"/>
+          </a:xfrm>
+          <a:prstGeom prst="rect">
+            <a:avLst/>
+          </a:prstGeom>
+          <a:noFill/>
+        </p:spPr>
+        <p:txBody>
+          <a:bodyPr wrap="square">
+            <a:spAutoFit/>
+          </a:bodyPr>
+          <a:lstStyle/>
+          <a:p>
+            <a:pPr algn="l"/>
+            <a:r>
+              <a:rPr sz="1400" b="0">
+                <a:solidFill>
+                  <a:srgbClr val="1A1A2E"/>
+                </a:solidFill>
+                <a:latin typeface="Segoe UI"/>
+              </a:rPr>
+              <a:t>•  Spark liczy to rozproszenie na klastrze Glue — dlatego 2,7 mln wierszy w ~4 min</a:t>
+            </a:r>
+          </a:p>
+        </p:txBody>
+      </p:sp>
+    </p:spTree>
+  </p:cSld>
+  <p:clrMapOvr>
+    <a:masterClrMapping/>
+  </p:clrMapOvr>
+</p:sld>
+</file>
+
 <file path=ppt/slides/slide2.xml><?xml version="1.0" encoding="utf-8"?>
 <p:sld xmlns:a="http://schemas.openxmlformats.org/drawingml/2006/main" xmlns:p="http://schemas.openxmlformats.org/presentationml/2006/main" xmlns:r="http://schemas.openxmlformats.org/officeDocument/2006/relationships">
   <p:cSld>
@@ -6267,6 +9137,1001 @@
                 <a:latin typeface="Consolas"/>
               </a:rPr>
               <a:t>RAPORT: Yemen × lipiec 2025 × Battles → suma ofiar               ← Power BI liczy po gwieździe</a:t>
+            </a:r>
+          </a:p>
+        </p:txBody>
+      </p:sp>
+    </p:spTree>
+  </p:cSld>
+  <p:clrMapOvr>
+    <a:masterClrMapping/>
+  </p:clrMapOvr>
+</p:sld>
+</file>
+
+<file path=ppt/slides/slide20.xml><?xml version="1.0" encoding="utf-8"?>
+<p:sld xmlns:a="http://schemas.openxmlformats.org/drawingml/2006/main" xmlns:p="http://schemas.openxmlformats.org/presentationml/2006/main" xmlns:r="http://schemas.openxmlformats.org/officeDocument/2006/relationships">
+  <p:cSld>
+    <p:bg>
+      <p:bgPr>
+        <a:solidFill>
+          <a:srgbClr val="F7F7F5"/>
+        </a:solidFill>
+        <a:effectLst/>
+      </p:bgPr>
+    </p:bg>
+    <p:spTree>
+      <p:nvGrpSpPr>
+        <p:cNvPr id="1" name=""/>
+        <p:cNvGrpSpPr/>
+        <p:nvPr/>
+      </p:nvGrpSpPr>
+      <p:grpSpPr/>
+      <p:sp>
+        <p:nvSpPr>
+          <p:cNvPr id="2" name="Rectangle 1"/>
+          <p:cNvSpPr/>
+          <p:nvPr/>
+        </p:nvSpPr>
+        <p:spPr>
+          <a:xfrm>
+            <a:off x="0" y="0"/>
+            <a:ext cx="12191695" cy="146304"/>
+          </a:xfrm>
+          <a:prstGeom prst="rect">
+            <a:avLst/>
+          </a:prstGeom>
+          <a:solidFill>
+            <a:srgbClr val="1F6F8B"/>
+          </a:solidFill>
+          <a:ln>
+            <a:noFill/>
+          </a:ln>
+        </p:spPr>
+        <p:style>
+          <a:lnRef idx="1">
+            <a:schemeClr val="accent1"/>
+          </a:lnRef>
+          <a:fillRef idx="3">
+            <a:schemeClr val="accent1"/>
+          </a:fillRef>
+          <a:effectRef idx="2">
+            <a:schemeClr val="accent1"/>
+          </a:effectRef>
+          <a:fontRef idx="minor">
+            <a:schemeClr val="lt1"/>
+          </a:fontRef>
+        </p:style>
+        <p:txBody>
+          <a:bodyPr rtlCol="0" anchor="ctr"/>
+          <a:lstStyle/>
+          <a:p>
+            <a:pPr algn="ctr"/>
+          </a:p>
+        </p:txBody>
+      </p:sp>
+      <p:sp>
+        <p:nvSpPr>
+          <p:cNvPr id="3" name="TextBox 2"/>
+          <p:cNvSpPr txBox="1"/>
+          <p:nvPr/>
+        </p:nvSpPr>
+        <p:spPr>
+          <a:xfrm>
+            <a:off x="457200" y="256032"/>
+            <a:ext cx="11277295" cy="566928"/>
+          </a:xfrm>
+          <a:prstGeom prst="rect">
+            <a:avLst/>
+          </a:prstGeom>
+          <a:noFill/>
+        </p:spPr>
+        <p:txBody>
+          <a:bodyPr wrap="square">
+            <a:spAutoFit/>
+          </a:bodyPr>
+          <a:lstStyle/>
+          <a:p>
+            <a:pPr algn="l"/>
+            <a:r>
+              <a:rPr sz="2600" b="1">
+                <a:solidFill>
+                  <a:srgbClr val="1F6F8B"/>
+                </a:solidFill>
+                <a:latin typeface="Segoe UI"/>
+              </a:rPr>
+              <a:t>Pod maską: gold i gwiazda (Athena CTAS)</a:t>
+            </a:r>
+          </a:p>
+        </p:txBody>
+      </p:sp>
+      <p:sp>
+        <p:nvSpPr>
+          <p:cNvPr id="4" name="TextBox 3"/>
+          <p:cNvSpPr txBox="1"/>
+          <p:nvPr/>
+        </p:nvSpPr>
+        <p:spPr>
+          <a:xfrm>
+            <a:off x="457200" y="804672"/>
+            <a:ext cx="11277295" cy="347472"/>
+          </a:xfrm>
+          <a:prstGeom prst="rect">
+            <a:avLst/>
+          </a:prstGeom>
+          <a:noFill/>
+        </p:spPr>
+        <p:txBody>
+          <a:bodyPr wrap="square">
+            <a:spAutoFit/>
+          </a:bodyPr>
+          <a:lstStyle/>
+          <a:p>
+            <a:pPr algn="l"/>
+            <a:r>
+              <a:rPr sz="1300" b="0">
+                <a:solidFill>
+                  <a:srgbClr val="6B6B7B"/>
+                </a:solidFill>
+                <a:latin typeface="Segoe UI"/>
+              </a:rPr>
+              <a:t>każda tabela = DROP + wyczyszczenie prefixu + CREATE TABLE AS SELECT</a:t>
+            </a:r>
+          </a:p>
+        </p:txBody>
+      </p:sp>
+      <p:sp>
+        <p:nvSpPr>
+          <p:cNvPr id="5" name="Rectangle 4"/>
+          <p:cNvSpPr/>
+          <p:nvPr/>
+        </p:nvSpPr>
+        <p:spPr>
+          <a:xfrm>
+            <a:off x="548640" y="1325880"/>
+            <a:ext cx="11155680" cy="2651760"/>
+          </a:xfrm>
+          <a:prstGeom prst="rect">
+            <a:avLst/>
+          </a:prstGeom>
+          <a:solidFill>
+            <a:srgbClr val="FFFFFF"/>
+          </a:solidFill>
+          <a:ln w="12700">
+            <a:solidFill>
+              <a:srgbClr val="1F6F8B"/>
+            </a:solidFill>
+          </a:ln>
+        </p:spPr>
+        <p:style>
+          <a:lnRef idx="1">
+            <a:schemeClr val="accent1"/>
+          </a:lnRef>
+          <a:fillRef idx="3">
+            <a:schemeClr val="accent1"/>
+          </a:fillRef>
+          <a:effectRef idx="2">
+            <a:schemeClr val="accent1"/>
+          </a:effectRef>
+          <a:fontRef idx="minor">
+            <a:schemeClr val="lt1"/>
+          </a:fontRef>
+        </p:style>
+        <p:txBody>
+          <a:bodyPr rtlCol="0" anchor="ctr"/>
+          <a:lstStyle/>
+          <a:p>
+            <a:pPr algn="ctr"/>
+          </a:p>
+        </p:txBody>
+      </p:sp>
+      <p:sp>
+        <p:nvSpPr>
+          <p:cNvPr id="6" name="TextBox 5"/>
+          <p:cNvSpPr txBox="1"/>
+          <p:nvPr/>
+        </p:nvSpPr>
+        <p:spPr>
+          <a:xfrm>
+            <a:off x="685800" y="1399032"/>
+            <a:ext cx="10881359" cy="292608"/>
+          </a:xfrm>
+          <a:prstGeom prst="rect">
+            <a:avLst/>
+          </a:prstGeom>
+          <a:noFill/>
+        </p:spPr>
+        <p:txBody>
+          <a:bodyPr wrap="square">
+            <a:spAutoFit/>
+          </a:bodyPr>
+          <a:lstStyle/>
+          <a:p>
+            <a:pPr algn="l"/>
+            <a:r>
+              <a:rPr sz="1200" b="1">
+                <a:solidFill>
+                  <a:srgbClr val="1F6F8B"/>
+                </a:solidFill>
+                <a:latin typeface="Segoe UI"/>
+              </a:rPr>
+              <a:t>wymiar — main/sql/10_star_schema.sql</a:t>
+            </a:r>
+          </a:p>
+        </p:txBody>
+      </p:sp>
+      <p:sp>
+        <p:nvSpPr>
+          <p:cNvPr id="7" name="TextBox 6"/>
+          <p:cNvSpPr txBox="1"/>
+          <p:nvPr/>
+        </p:nvSpPr>
+        <p:spPr>
+          <a:xfrm>
+            <a:off x="685800" y="1728216"/>
+            <a:ext cx="10881359" cy="2194560"/>
+          </a:xfrm>
+          <a:prstGeom prst="rect">
+            <a:avLst/>
+          </a:prstGeom>
+          <a:noFill/>
+        </p:spPr>
+        <p:txBody>
+          <a:bodyPr wrap="square">
+            <a:spAutoFit/>
+          </a:bodyPr>
+          <a:lstStyle/>
+          <a:p>
+            <a:pPr algn="l"/>
+            <a:r>
+              <a:rPr sz="1200" b="0">
+                <a:solidFill>
+                  <a:srgbClr val="1A1A2E"/>
+                </a:solidFill>
+                <a:latin typeface="Consolas"/>
+              </a:rPr>
+              <a:t>DROP TABLE IF EXISTS acled_dev.dim_country;            -- 1. usuń definicję</a:t>
+            </a:r>
+          </a:p>
+          <a:p>
+            <a:pPr algn="l"/>
+            <a:r>
+              <a:rPr sz="1200" b="0">
+                <a:solidFill>
+                  <a:srgbClr val="1A1A2E"/>
+                </a:solidFill>
+                <a:latin typeface="Consolas"/>
+              </a:rPr>
+              <a:t>-- 2. skasuj pliki: s3://mw-acled-gold-dev/star/dim_country/   (boto3)</a:t>
+            </a:r>
+          </a:p>
+          <a:p>
+            <a:pPr algn="l"/>
+            <a:r>
+              <a:rPr sz="1200" b="0">
+                <a:solidFill>
+                  <a:srgbClr val="1A1A2E"/>
+                </a:solidFill>
+                <a:latin typeface="Consolas"/>
+              </a:rPr>
+              <a:t>CREATE TABLE acled_dev.dim_country                      -- 3. zbuduj od nowa</a:t>
+            </a:r>
+          </a:p>
+          <a:p>
+            <a:pPr algn="l"/>
+            <a:r>
+              <a:rPr sz="1200" b="0">
+                <a:solidFill>
+                  <a:srgbClr val="1A1A2E"/>
+                </a:solidFill>
+                <a:latin typeface="Consolas"/>
+              </a:rPr>
+              <a:t>WITH (format='PARQUET',</a:t>
+            </a:r>
+          </a:p>
+          <a:p>
+            <a:pPr algn="l"/>
+            <a:r>
+              <a:rPr sz="1200" b="0">
+                <a:solidFill>
+                  <a:srgbClr val="1A1A2E"/>
+                </a:solidFill>
+                <a:latin typeface="Consolas"/>
+              </a:rPr>
+              <a:t>      external_location='s3://mw-acled-gold-dev/star/dim_country/') AS</a:t>
+            </a:r>
+          </a:p>
+          <a:p>
+            <a:pPr algn="l"/>
+            <a:r>
+              <a:rPr sz="1200" b="0">
+                <a:solidFill>
+                  <a:srgbClr val="1A1A2E"/>
+                </a:solidFill>
+                <a:latin typeface="Consolas"/>
+              </a:rPr>
+              <a:t>SELECT ROW_NUMBER() OVER (ORDER BY iso) AS id_country, iso, country, region</a:t>
+            </a:r>
+          </a:p>
+          <a:p>
+            <a:pPr algn="l"/>
+            <a:r>
+              <a:rPr sz="1200" b="0">
+                <a:solidFill>
+                  <a:srgbClr val="1A1A2E"/>
+                </a:solidFill>
+                <a:latin typeface="Consolas"/>
+              </a:rPr>
+              <a:t>FROM (... GROUP BY iso)</a:t>
+            </a:r>
+          </a:p>
+          <a:p>
+            <a:pPr algn="l"/>
+            <a:r>
+              <a:rPr sz="1200" b="0">
+                <a:solidFill>
+                  <a:srgbClr val="1A1A2E"/>
+                </a:solidFill>
+                <a:latin typeface="Consolas"/>
+              </a:rPr>
+              <a:t>UNION ALL SELECT -1, NULL, 'Unknown', 'Unknown';        -- wiersz na braki</a:t>
+            </a:r>
+          </a:p>
+        </p:txBody>
+      </p:sp>
+      <p:sp>
+        <p:nvSpPr>
+          <p:cNvPr id="8" name="Rectangle 7"/>
+          <p:cNvSpPr/>
+          <p:nvPr/>
+        </p:nvSpPr>
+        <p:spPr>
+          <a:xfrm>
+            <a:off x="548640" y="4160520"/>
+            <a:ext cx="11155680" cy="1737360"/>
+          </a:xfrm>
+          <a:prstGeom prst="rect">
+            <a:avLst/>
+          </a:prstGeom>
+          <a:solidFill>
+            <a:srgbClr val="FFFFFF"/>
+          </a:solidFill>
+          <a:ln w="12700">
+            <a:solidFill>
+              <a:srgbClr val="1F6F8B"/>
+            </a:solidFill>
+          </a:ln>
+        </p:spPr>
+        <p:style>
+          <a:lnRef idx="1">
+            <a:schemeClr val="accent1"/>
+          </a:lnRef>
+          <a:fillRef idx="3">
+            <a:schemeClr val="accent1"/>
+          </a:fillRef>
+          <a:effectRef idx="2">
+            <a:schemeClr val="accent1"/>
+          </a:effectRef>
+          <a:fontRef idx="minor">
+            <a:schemeClr val="lt1"/>
+          </a:fontRef>
+        </p:style>
+        <p:txBody>
+          <a:bodyPr rtlCol="0" anchor="ctr"/>
+          <a:lstStyle/>
+          <a:p>
+            <a:pPr algn="ctr"/>
+          </a:p>
+        </p:txBody>
+      </p:sp>
+      <p:sp>
+        <p:nvSpPr>
+          <p:cNvPr id="9" name="TextBox 8"/>
+          <p:cNvSpPr txBox="1"/>
+          <p:nvPr/>
+        </p:nvSpPr>
+        <p:spPr>
+          <a:xfrm>
+            <a:off x="685800" y="4233672"/>
+            <a:ext cx="10881359" cy="292608"/>
+          </a:xfrm>
+          <a:prstGeom prst="rect">
+            <a:avLst/>
+          </a:prstGeom>
+          <a:noFill/>
+        </p:spPr>
+        <p:txBody>
+          <a:bodyPr wrap="square">
+            <a:spAutoFit/>
+          </a:bodyPr>
+          <a:lstStyle/>
+          <a:p>
+            <a:pPr algn="l"/>
+            <a:r>
+              <a:rPr sz="1200" b="1">
+                <a:solidFill>
+                  <a:srgbClr val="1F6F8B"/>
+                </a:solidFill>
+                <a:latin typeface="Segoe UI"/>
+              </a:rPr>
+              <a:t>fakt — lookup surogatów</a:t>
+            </a:r>
+          </a:p>
+        </p:txBody>
+      </p:sp>
+      <p:sp>
+        <p:nvSpPr>
+          <p:cNvPr id="10" name="TextBox 9"/>
+          <p:cNvSpPr txBox="1"/>
+          <p:nvPr/>
+        </p:nvSpPr>
+        <p:spPr>
+          <a:xfrm>
+            <a:off x="685800" y="4562856"/>
+            <a:ext cx="10881359" cy="1280160"/>
+          </a:xfrm>
+          <a:prstGeom prst="rect">
+            <a:avLst/>
+          </a:prstGeom>
+          <a:noFill/>
+        </p:spPr>
+        <p:txBody>
+          <a:bodyPr wrap="square">
+            <a:spAutoFit/>
+          </a:bodyPr>
+          <a:lstStyle/>
+          <a:p>
+            <a:pPr algn="l"/>
+            <a:r>
+              <a:rPr sz="1200" b="0">
+                <a:solidFill>
+                  <a:srgbClr val="1A1A2E"/>
+                </a:solidFill>
+                <a:latin typeface="Consolas"/>
+              </a:rPr>
+              <a:t>SELECT COALESCE(dc.id_country,-1) id_country, COALESCE(dd.id_date,-1) id_date, ...,</a:t>
+            </a:r>
+          </a:p>
+          <a:p>
+            <a:pPr algn="l"/>
+            <a:r>
+              <a:rPr sz="1200" b="0">
+                <a:solidFill>
+                  <a:srgbClr val="1A1A2E"/>
+                </a:solidFill>
+                <a:latin typeface="Consolas"/>
+              </a:rPr>
+              <a:t>       g.fatalities</a:t>
+            </a:r>
+          </a:p>
+          <a:p>
+            <a:pPr algn="l"/>
+            <a:r>
+              <a:rPr sz="1200" b="0">
+                <a:solidFill>
+                  <a:srgbClr val="1A1A2E"/>
+                </a:solidFill>
+                <a:latin typeface="Consolas"/>
+              </a:rPr>
+              <a:t>FROM gold_events_wide g</a:t>
+            </a:r>
+          </a:p>
+          <a:p>
+            <a:pPr algn="l"/>
+            <a:r>
+              <a:rPr sz="1200" b="0">
+                <a:solidFill>
+                  <a:srgbClr val="1A1A2E"/>
+                </a:solidFill>
+                <a:latin typeface="Consolas"/>
+              </a:rPr>
+              <a:t>LEFT JOIN dim_country dc ON g.iso = dc.iso          -- lookup klucza naturalnego → surogat</a:t>
+            </a:r>
+          </a:p>
+          <a:p>
+            <a:pPr algn="l"/>
+            <a:r>
+              <a:rPr sz="1200" b="0">
+                <a:solidFill>
+                  <a:srgbClr val="1A1A2E"/>
+                </a:solidFill>
+                <a:latin typeface="Consolas"/>
+              </a:rPr>
+              <a:t>LEFT JOIN dim_date dd ON ... ;                      -- LEFT: żadnego wiersza nie gubimy</a:t>
+            </a:r>
+          </a:p>
+        </p:txBody>
+      </p:sp>
+    </p:spTree>
+  </p:cSld>
+  <p:clrMapOvr>
+    <a:masterClrMapping/>
+  </p:clrMapOvr>
+</p:sld>
+</file>
+
+<file path=ppt/slides/slide21.xml><?xml version="1.0" encoding="utf-8"?>
+<p:sld xmlns:a="http://schemas.openxmlformats.org/drawingml/2006/main" xmlns:p="http://schemas.openxmlformats.org/presentationml/2006/main" xmlns:r="http://schemas.openxmlformats.org/officeDocument/2006/relationships">
+  <p:cSld>
+    <p:bg>
+      <p:bgPr>
+        <a:solidFill>
+          <a:srgbClr val="F7F7F5"/>
+        </a:solidFill>
+        <a:effectLst/>
+      </p:bgPr>
+    </p:bg>
+    <p:spTree>
+      <p:nvGrpSpPr>
+        <p:cNvPr id="1" name=""/>
+        <p:cNvGrpSpPr/>
+        <p:nvPr/>
+      </p:nvGrpSpPr>
+      <p:grpSpPr/>
+      <p:sp>
+        <p:nvSpPr>
+          <p:cNvPr id="2" name="Rectangle 1"/>
+          <p:cNvSpPr/>
+          <p:nvPr/>
+        </p:nvSpPr>
+        <p:spPr>
+          <a:xfrm>
+            <a:off x="0" y="0"/>
+            <a:ext cx="12191695" cy="146304"/>
+          </a:xfrm>
+          <a:prstGeom prst="rect">
+            <a:avLst/>
+          </a:prstGeom>
+          <a:solidFill>
+            <a:srgbClr val="1F6F8B"/>
+          </a:solidFill>
+          <a:ln>
+            <a:noFill/>
+          </a:ln>
+        </p:spPr>
+        <p:style>
+          <a:lnRef idx="1">
+            <a:schemeClr val="accent1"/>
+          </a:lnRef>
+          <a:fillRef idx="3">
+            <a:schemeClr val="accent1"/>
+          </a:fillRef>
+          <a:effectRef idx="2">
+            <a:schemeClr val="accent1"/>
+          </a:effectRef>
+          <a:fontRef idx="minor">
+            <a:schemeClr val="lt1"/>
+          </a:fontRef>
+        </p:style>
+        <p:txBody>
+          <a:bodyPr rtlCol="0" anchor="ctr"/>
+          <a:lstStyle/>
+          <a:p>
+            <a:pPr algn="ctr"/>
+          </a:p>
+        </p:txBody>
+      </p:sp>
+      <p:sp>
+        <p:nvSpPr>
+          <p:cNvPr id="3" name="TextBox 2"/>
+          <p:cNvSpPr txBox="1"/>
+          <p:nvPr/>
+        </p:nvSpPr>
+        <p:spPr>
+          <a:xfrm>
+            <a:off x="457200" y="256032"/>
+            <a:ext cx="11277295" cy="566928"/>
+          </a:xfrm>
+          <a:prstGeom prst="rect">
+            <a:avLst/>
+          </a:prstGeom>
+          <a:noFill/>
+        </p:spPr>
+        <p:txBody>
+          <a:bodyPr wrap="square">
+            <a:spAutoFit/>
+          </a:bodyPr>
+          <a:lstStyle/>
+          <a:p>
+            <a:pPr algn="l"/>
+            <a:r>
+              <a:rPr sz="2600" b="1">
+                <a:solidFill>
+                  <a:srgbClr val="1F6F8B"/>
+                </a:solidFill>
+                <a:latin typeface="Segoe UI"/>
+              </a:rPr>
+              <a:t>Pod maską: jak wygląda kod DAG-a</a:t>
+            </a:r>
+          </a:p>
+        </p:txBody>
+      </p:sp>
+      <p:sp>
+        <p:nvSpPr>
+          <p:cNvPr id="4" name="TextBox 3"/>
+          <p:cNvSpPr txBox="1"/>
+          <p:nvPr/>
+        </p:nvSpPr>
+        <p:spPr>
+          <a:xfrm>
+            <a:off x="457200" y="804672"/>
+            <a:ext cx="11277295" cy="347472"/>
+          </a:xfrm>
+          <a:prstGeom prst="rect">
+            <a:avLst/>
+          </a:prstGeom>
+          <a:noFill/>
+        </p:spPr>
+        <p:txBody>
+          <a:bodyPr wrap="square">
+            <a:spAutoFit/>
+          </a:bodyPr>
+          <a:lstStyle/>
+          <a:p>
+            <a:pPr algn="l"/>
+            <a:r>
+              <a:rPr sz="1300" b="0">
+                <a:solidFill>
+                  <a:srgbClr val="6B6B7B"/>
+                </a:solidFill>
+                <a:latin typeface="Segoe UI"/>
+              </a:rPr>
+              <a:t>Python; @task = funkcja staje się zadaniem w grafie</a:t>
+            </a:r>
+          </a:p>
+        </p:txBody>
+      </p:sp>
+      <p:sp>
+        <p:nvSpPr>
+          <p:cNvPr id="5" name="Rectangle 4"/>
+          <p:cNvSpPr/>
+          <p:nvPr/>
+        </p:nvSpPr>
+        <p:spPr>
+          <a:xfrm>
+            <a:off x="548640" y="1325880"/>
+            <a:ext cx="11155680" cy="3200400"/>
+          </a:xfrm>
+          <a:prstGeom prst="rect">
+            <a:avLst/>
+          </a:prstGeom>
+          <a:solidFill>
+            <a:srgbClr val="FFFFFF"/>
+          </a:solidFill>
+          <a:ln w="12700">
+            <a:solidFill>
+              <a:srgbClr val="1F6F8B"/>
+            </a:solidFill>
+          </a:ln>
+        </p:spPr>
+        <p:style>
+          <a:lnRef idx="1">
+            <a:schemeClr val="accent1"/>
+          </a:lnRef>
+          <a:fillRef idx="3">
+            <a:schemeClr val="accent1"/>
+          </a:fillRef>
+          <a:effectRef idx="2">
+            <a:schemeClr val="accent1"/>
+          </a:effectRef>
+          <a:fontRef idx="minor">
+            <a:schemeClr val="lt1"/>
+          </a:fontRef>
+        </p:style>
+        <p:txBody>
+          <a:bodyPr rtlCol="0" anchor="ctr"/>
+          <a:lstStyle/>
+          <a:p>
+            <a:pPr algn="ctr"/>
+          </a:p>
+        </p:txBody>
+      </p:sp>
+      <p:sp>
+        <p:nvSpPr>
+          <p:cNvPr id="6" name="TextBox 5"/>
+          <p:cNvSpPr txBox="1"/>
+          <p:nvPr/>
+        </p:nvSpPr>
+        <p:spPr>
+          <a:xfrm>
+            <a:off x="685800" y="1399032"/>
+            <a:ext cx="10881359" cy="292608"/>
+          </a:xfrm>
+          <a:prstGeom prst="rect">
+            <a:avLst/>
+          </a:prstGeom>
+          <a:noFill/>
+        </p:spPr>
+        <p:txBody>
+          <a:bodyPr wrap="square">
+            <a:spAutoFit/>
+          </a:bodyPr>
+          <a:lstStyle/>
+          <a:p>
+            <a:pPr algn="l"/>
+            <a:r>
+              <a:rPr sz="1200" b="1">
+                <a:solidFill>
+                  <a:srgbClr val="1F6F8B"/>
+                </a:solidFill>
+                <a:latin typeface="Segoe UI"/>
+              </a:rPr>
+              <a:t>airflow/dags/acled_pipeline.py (skrót)</a:t>
+            </a:r>
+          </a:p>
+        </p:txBody>
+      </p:sp>
+      <p:sp>
+        <p:nvSpPr>
+          <p:cNvPr id="7" name="TextBox 6"/>
+          <p:cNvSpPr txBox="1"/>
+          <p:nvPr/>
+        </p:nvSpPr>
+        <p:spPr>
+          <a:xfrm>
+            <a:off x="685800" y="1728216"/>
+            <a:ext cx="10881359" cy="2743200"/>
+          </a:xfrm>
+          <a:prstGeom prst="rect">
+            <a:avLst/>
+          </a:prstGeom>
+          <a:noFill/>
+        </p:spPr>
+        <p:txBody>
+          <a:bodyPr wrap="square">
+            <a:spAutoFit/>
+          </a:bodyPr>
+          <a:lstStyle/>
+          <a:p>
+            <a:pPr algn="l"/>
+            <a:r>
+              <a:rPr sz="1200" b="0">
+                <a:solidFill>
+                  <a:srgbClr val="1A1A2E"/>
+                </a:solidFill>
+                <a:latin typeface="Consolas"/>
+              </a:rPr>
+              <a:t>@dag(dag_id='acled_pipeline', schedule=None,</a:t>
+            </a:r>
+          </a:p>
+          <a:p>
+            <a:pPr algn="l"/>
+            <a:r>
+              <a:rPr sz="1200" b="0">
+                <a:solidFill>
+                  <a:srgbClr val="1A1A2E"/>
+                </a:solidFill>
+                <a:latin typeface="Consolas"/>
+              </a:rPr>
+              <a:t>     params={'run_glue': Param(False, type='boolean')})</a:t>
+            </a:r>
+          </a:p>
+          <a:p>
+            <a:pPr algn="l"/>
+            <a:r>
+              <a:rPr sz="1200" b="0">
+                <a:solidFill>
+                  <a:srgbClr val="1A1A2E"/>
+                </a:solidFill>
+                <a:latin typeface="Consolas"/>
+              </a:rPr>
+              <a:t>def pipeline():</a:t>
+            </a:r>
+          </a:p>
+          <a:p>
+            <a:pPr algn="l"/>
+            <a:r>
+              <a:rPr sz="1200" b="0">
+                <a:solidFill>
+                  <a:srgbClr val="1A1A2E"/>
+                </a:solidFill>
+                <a:latin typeface="Consolas"/>
+              </a:rPr>
+              <a:t>    @task</a:t>
+            </a:r>
+          </a:p>
+          <a:p>
+            <a:pPr algn="l"/>
+            <a:r>
+              <a:rPr sz="1200" b="0">
+                <a:solidFill>
+                  <a:srgbClr val="1A1A2E"/>
+                </a:solidFill>
+                <a:latin typeface="Consolas"/>
+              </a:rPr>
+              <a:t>    def gold_events_wide():</a:t>
+            </a:r>
+          </a:p>
+          <a:p>
+            <a:pPr algn="l"/>
+            <a:r>
+              <a:rPr sz="1200" b="0">
+                <a:solidFill>
+                  <a:srgbClr val="1A1A2E"/>
+                </a:solidFill>
+                <a:latin typeface="Consolas"/>
+              </a:rPr>
+              <a:t>        _rebuild('gold_events_wide', 'events_wide/', GOLD_EVENTS_WIDE)</a:t>
+            </a:r>
+          </a:p>
+          <a:p>
+            <a:pPr algn="l"/>
+            <a:r>
+              <a:rPr sz="1200" b="0">
+                <a:solidFill>
+                  <a:srgbClr val="1A1A2E"/>
+                </a:solidFill>
+                <a:latin typeface="Consolas"/>
+              </a:rPr>
+              <a:t>    @task</a:t>
+            </a:r>
+          </a:p>
+          <a:p>
+            <a:pPr algn="l"/>
+            <a:r>
+              <a:rPr sz="1200" b="0">
+                <a:solidFill>
+                  <a:srgbClr val="1A1A2E"/>
+                </a:solidFill>
+                <a:latin typeface="Consolas"/>
+              </a:rPr>
+              <a:t>    def validate():</a:t>
+            </a:r>
+          </a:p>
+          <a:p>
+            <a:pPr algn="l"/>
+            <a:r>
+              <a:rPr sz="1200" b="0">
+                <a:solidFill>
+                  <a:srgbClr val="1A1A2E"/>
+                </a:solidFill>
+                <a:latin typeface="Consolas"/>
+              </a:rPr>
+              <a:t>        ...assert stats['silver'] == stats['gold'] == stats['fact']</a:t>
+            </a:r>
+          </a:p>
+          <a:p>
+            <a:pPr algn="l"/>
+          </a:p>
+          <a:p>
+            <a:pPr algn="l"/>
+            <a:r>
+              <a:rPr sz="1200" b="0">
+                <a:solidFill>
+                  <a:srgbClr val="1A1A2E"/>
+                </a:solidFill>
+                <a:latin typeface="Consolas"/>
+              </a:rPr>
+              <a:t>    gold &gt;&gt; dims          # strzałki grafu: najpierw gold, potem wymiary</a:t>
+            </a:r>
+          </a:p>
+          <a:p>
+            <a:pPr algn="l"/>
+            <a:r>
+              <a:rPr sz="1200" b="0">
+                <a:solidFill>
+                  <a:srgbClr val="1A1A2E"/>
+                </a:solidFill>
+                <a:latin typeface="Consolas"/>
+              </a:rPr>
+              <a:t>    dims &gt;&gt; fact          # fakt czeka na WSZYSTKIE wymiary</a:t>
+            </a:r>
+          </a:p>
+          <a:p>
+            <a:pPr algn="l"/>
+            <a:r>
+              <a:rPr sz="1200" b="0">
+                <a:solidFill>
+                  <a:srgbClr val="1A1A2E"/>
+                </a:solidFill>
+                <a:latin typeface="Consolas"/>
+              </a:rPr>
+              <a:t>    fact &gt;&gt; validate()    # walidacja zawsze na końcu</a:t>
+            </a:r>
+          </a:p>
+        </p:txBody>
+      </p:sp>
+      <p:sp>
+        <p:nvSpPr>
+          <p:cNvPr id="8" name="TextBox 7"/>
+          <p:cNvSpPr txBox="1"/>
+          <p:nvPr/>
+        </p:nvSpPr>
+        <p:spPr>
+          <a:xfrm>
+            <a:off x="548640" y="4754880"/>
+            <a:ext cx="11155680" cy="649224"/>
+          </a:xfrm>
+          <a:prstGeom prst="rect">
+            <a:avLst/>
+          </a:prstGeom>
+          <a:noFill/>
+        </p:spPr>
+        <p:txBody>
+          <a:bodyPr wrap="square">
+            <a:spAutoFit/>
+          </a:bodyPr>
+          <a:lstStyle/>
+          <a:p>
+            <a:pPr algn="l"/>
+            <a:r>
+              <a:rPr sz="1400" b="1">
+                <a:solidFill>
+                  <a:srgbClr val="1F6F8B"/>
+                </a:solidFill>
+                <a:latin typeface="Segoe UI"/>
+              </a:rPr>
+              <a:t>•  operator &gt;&gt; rysuje strzałki grafu — z tego Airflow wie o kolejności i równoległości</a:t>
+            </a:r>
+          </a:p>
+        </p:txBody>
+      </p:sp>
+      <p:sp>
+        <p:nvSpPr>
+          <p:cNvPr id="9" name="TextBox 8"/>
+          <p:cNvSpPr txBox="1"/>
+          <p:nvPr/>
+        </p:nvSpPr>
+        <p:spPr>
+          <a:xfrm>
+            <a:off x="548640" y="5212080"/>
+            <a:ext cx="11155680" cy="649224"/>
+          </a:xfrm>
+          <a:prstGeom prst="rect">
+            <a:avLst/>
+          </a:prstGeom>
+          <a:noFill/>
+        </p:spPr>
+        <p:txBody>
+          <a:bodyPr wrap="square">
+            <a:spAutoFit/>
+          </a:bodyPr>
+          <a:lstStyle/>
+          <a:p>
+            <a:pPr algn="l"/>
+            <a:r>
+              <a:rPr sz="1400" b="0">
+                <a:solidFill>
+                  <a:srgbClr val="1A1A2E"/>
+                </a:solidFill>
+                <a:latin typeface="Segoe UI"/>
+              </a:rPr>
+              <a:t>•  Param = pole w formularzu przy Trigger (nasze run_glue); schedule=None = tylko ręczne uruchomienie</a:t>
+            </a:r>
+          </a:p>
+        </p:txBody>
+      </p:sp>
+      <p:sp>
+        <p:nvSpPr>
+          <p:cNvPr id="10" name="TextBox 9"/>
+          <p:cNvSpPr txBox="1"/>
+          <p:nvPr/>
+        </p:nvSpPr>
+        <p:spPr>
+          <a:xfrm>
+            <a:off x="548640" y="5669280"/>
+            <a:ext cx="11155680" cy="649224"/>
+          </a:xfrm>
+          <a:prstGeom prst="rect">
+            <a:avLst/>
+          </a:prstGeom>
+          <a:noFill/>
+        </p:spPr>
+        <p:txBody>
+          <a:bodyPr wrap="square">
+            <a:spAutoFit/>
+          </a:bodyPr>
+          <a:lstStyle/>
+          <a:p>
+            <a:pPr algn="l"/>
+            <a:r>
+              <a:rPr sz="1400" b="0">
+                <a:solidFill>
+                  <a:srgbClr val="1A1A2E"/>
+                </a:solidFill>
+                <a:latin typeface="Segoe UI"/>
+              </a:rPr>
+              <a:t>•  kod DAG-a to definicja, nie wykonanie — taski odpala scheduler w osobnych procesach</a:t>
             </a:r>
           </a:p>
         </p:txBody>

</xml_diff>